<commit_message>
docs: remove stale guidance and sync WBS
</commit_message>
<xml_diff>
--- a/exports/knowledge_flow/mighty_skill_bridge_ceo_presentation_2026-06-02.pptx
+++ b/exports/knowledge_flow/mighty_skill_bridge_ceo_presentation_2026-06-02.pptx
@@ -4584,7 +4584,7 @@
                 </a:solidFill>
                 <a:latin typeface="Yu Gothic"/>
               </a:rPr>
-              <a:t>79 tasks</a:t>
+              <a:t>80 tasks</a:t>
             </a:r>
           </a:p>
         </p:txBody>
@@ -6000,7 +6000,7 @@
               </a:defRPr>
             </a:pPr>
             <a:r>
-              <a:t>NotebookLM sources ready: 20</a:t>
+              <a:t>NotebookLM sources ready: 21</a:t>
             </a:r>
           </a:p>
           <a:p>
@@ -6414,7 +6414,7 @@
                 </a:solidFill>
                 <a:latin typeface="Yu Gothic"/>
               </a:rPr>
-              <a:t>14 source ready
+              <a:t>21 source ready
 Agent Brief / CEO outline取得済み</a:t>
             </a:r>
           </a:p>
@@ -7693,7 +7693,7 @@
                 </a:solidFill>
                 <a:latin typeface="Yu Gothic"/>
               </a:rPr>
-              <a:t>Workspace所有で14件</a:t>
+              <a:t>Workspace所有で21件</a:t>
             </a:r>
           </a:p>
         </p:txBody>
@@ -12122,7 +12122,7 @@
               </a:defRPr>
             </a:pPr>
             <a:r>
-              <a:t>Issue tracking: GitHub Issues #1-#11</a:t>
+              <a:t>Issue tracking: GitHub Issues #1-#11/#13/#14/#16</a:t>
             </a:r>
           </a:p>
         </p:txBody>

</xml_diff>

<commit_message>
feat: delete completed WBS calendar events
</commit_message>
<xml_diff>
--- a/exports/knowledge_flow/mighty_skill_bridge_ceo_presentation_2026-06-02.pptx
+++ b/exports/knowledge_flow/mighty_skill_bridge_ceo_presentation_2026-06-02.pptx
@@ -4584,7 +4584,7 @@
                 </a:solidFill>
                 <a:latin typeface="Yu Gothic"/>
               </a:rPr>
-              <a:t>80 tasks</a:t>
+              <a:t>81 tasks</a:t>
             </a:r>
           </a:p>
         </p:txBody>
@@ -6000,7 +6000,7 @@
               </a:defRPr>
             </a:pPr>
             <a:r>
-              <a:t>NotebookLM sources ready: 21</a:t>
+              <a:t>NotebookLM sources ready: 22</a:t>
             </a:r>
           </a:p>
           <a:p>
@@ -6414,7 +6414,7 @@
                 </a:solidFill>
                 <a:latin typeface="Yu Gothic"/>
               </a:rPr>
-              <a:t>21 source ready
+              <a:t>22 source ready
 Agent Brief / CEO outline取得済み</a:t>
             </a:r>
           </a:p>
@@ -7693,7 +7693,7 @@
                 </a:solidFill>
                 <a:latin typeface="Yu Gothic"/>
               </a:rPr>
-              <a:t>Workspace所有で21件</a:t>
+              <a:t>Workspace所有で22件</a:t>
             </a:r>
           </a:p>
         </p:txBody>

</xml_diff>

<commit_message>
feat: complete phase 4 testing & T608 final rehearsal with unified scopes and multi-tab Sheets sync
</commit_message>
<xml_diff>
--- a/exports/knowledge_flow/mighty_skill_bridge_ceo_presentation_2026-06-02.pptx
+++ b/exports/knowledge_flow/mighty_skill_bridge_ceo_presentation_2026-06-02.pptx
@@ -4584,7 +4584,7 @@
                 </a:solidFill>
                 <a:latin typeface="Yu Gothic"/>
               </a:rPr>
-              <a:t>96 tasks</a:t>
+              <a:t>98 tasks</a:t>
             </a:r>
           </a:p>
         </p:txBody>
@@ -6000,7 +6000,7 @@
               </a:defRPr>
             </a:pPr>
             <a:r>
-              <a:t>NotebookLM sources ready: 22</a:t>
+              <a:t>NotebookLM sources ready: 25</a:t>
             </a:r>
           </a:p>
           <a:p>

</xml_diff>

<commit_message>
Harden Firebase deploy authentication
</commit_message>
<xml_diff>
--- a/exports/knowledge_flow/mighty_skill_bridge_ceo_presentation_2026-06-02.pptx
+++ b/exports/knowledge_flow/mighty_skill_bridge_ceo_presentation_2026-06-02.pptx
@@ -3240,7 +3240,7 @@
                 </a:solidFill>
                 <a:latin typeface="Yu Gothic"/>
               </a:rPr>
-              <a:t>01 / 08   NotebookLM CLI outline / notebook 75521ea6-6b9b-47b2-9508-50050d8ab2d5</a:t>
+              <a:t>01 / 08   NotebookLM CLI outline / notebook a235db10-d2c5-4ee3-9621-89efbb59e74c</a:t>
             </a:r>
           </a:p>
         </p:txBody>
@@ -4134,7 +4134,7 @@
                 </a:solidFill>
                 <a:latin typeface="Yu Gothic"/>
               </a:rPr>
-              <a:t>02 / 08   NotebookLM CLI outline / notebook 75521ea6-6b9b-47b2-9508-50050d8ab2d5</a:t>
+              <a:t>02 / 08   NotebookLM CLI outline / notebook a235db10-d2c5-4ee3-9621-89efbb59e74c</a:t>
             </a:r>
           </a:p>
         </p:txBody>
@@ -4584,7 +4584,7 @@
                 </a:solidFill>
                 <a:latin typeface="Yu Gothic"/>
               </a:rPr>
-              <a:t>137 tasks</a:t>
+              <a:t>139 tasks</a:t>
             </a:r>
           </a:p>
         </p:txBody>
@@ -5044,7 +5044,7 @@
                 </a:solidFill>
                 <a:latin typeface="Yu Gothic"/>
               </a:rPr>
-              <a:t>03 / 08   NotebookLM CLI outline / notebook 75521ea6-6b9b-47b2-9508-50050d8ab2d5</a:t>
+              <a:t>03 / 08   NotebookLM CLI outline / notebook a235db10-d2c5-4ee3-9621-89efbb59e74c</a:t>
             </a:r>
           </a:p>
         </p:txBody>
@@ -6000,7 +6000,7 @@
               </a:defRPr>
             </a:pPr>
             <a:r>
-              <a:t>NotebookLM sources ready: 28</a:t>
+              <a:t>NotebookLM sources ready: 31</a:t>
             </a:r>
           </a:p>
           <a:p>
@@ -6184,7 +6184,7 @@
                 </a:solidFill>
                 <a:latin typeface="Yu Gothic"/>
               </a:rPr>
-              <a:t>04 / 08   NotebookLM CLI outline / notebook 75521ea6-6b9b-47b2-9508-50050d8ab2d5</a:t>
+              <a:t>04 / 08   NotebookLM CLI outline / notebook a235db10-d2c5-4ee3-9621-89efbb59e74c</a:t>
             </a:r>
           </a:p>
         </p:txBody>
@@ -7393,7 +7393,7 @@
                 </a:solidFill>
                 <a:latin typeface="Yu Gothic"/>
               </a:rPr>
-              <a:t>05 / 08   NotebookLM CLI outline / notebook 75521ea6-6b9b-47b2-9508-50050d8ab2d5</a:t>
+              <a:t>05 / 08   NotebookLM CLI outline / notebook a235db10-d2c5-4ee3-9621-89efbb59e74c</a:t>
             </a:r>
           </a:p>
         </p:txBody>
@@ -8183,7 +8183,7 @@
               </a:defRPr>
             </a:pPr>
             <a:r>
-              <a:t>NotebookLM notebook: 75521ea6-6b9b-47b2-9508-50050d8ab2d5</a:t>
+              <a:t>NotebookLM notebook: a235db10-d2c5-4ee3-9621-89efbb59e74c</a:t>
             </a:r>
           </a:p>
           <a:p>
@@ -8383,7 +8383,7 @@
                 </a:solidFill>
                 <a:latin typeface="Yu Gothic"/>
               </a:rPr>
-              <a:t>06 / 08   NotebookLM CLI outline / notebook 75521ea6-6b9b-47b2-9508-50050d8ab2d5</a:t>
+              <a:t>06 / 08   NotebookLM CLI outline / notebook a235db10-d2c5-4ee3-9621-89efbb59e74c</a:t>
             </a:r>
           </a:p>
         </p:txBody>
@@ -9646,7 +9646,7 @@
                 </a:solidFill>
                 <a:latin typeface="Yu Gothic"/>
               </a:rPr>
-              <a:t>07 / 08   NotebookLM CLI outline / notebook 75521ea6-6b9b-47b2-9508-50050d8ab2d5</a:t>
+              <a:t>07 / 08   NotebookLM CLI outline / notebook a235db10-d2c5-4ee3-9621-89efbb59e74c</a:t>
             </a:r>
           </a:p>
         </p:txBody>
@@ -10750,7 +10750,7 @@
                 </a:solidFill>
                 <a:latin typeface="Yu Gothic"/>
               </a:rPr>
-              <a:t>08 / 08   NotebookLM CLI outline / notebook 75521ea6-6b9b-47b2-9508-50050d8ab2d5</a:t>
+              <a:t>08 / 08   NotebookLM CLI outline / notebook a235db10-d2c5-4ee3-9621-89efbb59e74c</a:t>
             </a:r>
           </a:p>
         </p:txBody>

</xml_diff>

<commit_message>
docs: WBS front-load realignment, add Firebase/Supabase lifecycle tasks and sync pilot_summary dashboard
</commit_message>
<xml_diff>
--- a/exports/knowledge_flow/mighty_skill_bridge_ceo_presentation_2026-06-02.pptx
+++ b/exports/knowledge_flow/mighty_skill_bridge_ceo_presentation_2026-06-02.pptx
@@ -3240,7 +3240,7 @@
                 </a:solidFill>
                 <a:latin typeface="Yu Gothic"/>
               </a:rPr>
-              <a:t>01 / 08   NotebookLM CLI outline / notebook a235db10-d2c5-4ee3-9621-89efbb59e74c</a:t>
+              <a:t>01 / 08   NotebookLM CLI outline / notebook 75521ea6-6b9b-47b2-9508-50050d8ab2d5</a:t>
             </a:r>
           </a:p>
         </p:txBody>
@@ -4134,7 +4134,7 @@
                 </a:solidFill>
                 <a:latin typeface="Yu Gothic"/>
               </a:rPr>
-              <a:t>02 / 08   NotebookLM CLI outline / notebook a235db10-d2c5-4ee3-9621-89efbb59e74c</a:t>
+              <a:t>02 / 08   NotebookLM CLI outline / notebook 75521ea6-6b9b-47b2-9508-50050d8ab2d5</a:t>
             </a:r>
           </a:p>
         </p:txBody>
@@ -4584,7 +4584,7 @@
                 </a:solidFill>
                 <a:latin typeface="Yu Gothic"/>
               </a:rPr>
-              <a:t>139 tasks</a:t>
+              <a:t>173 tasks</a:t>
             </a:r>
           </a:p>
         </p:txBody>
@@ -5044,7 +5044,7 @@
                 </a:solidFill>
                 <a:latin typeface="Yu Gothic"/>
               </a:rPr>
-              <a:t>03 / 08   NotebookLM CLI outline / notebook a235db10-d2c5-4ee3-9621-89efbb59e74c</a:t>
+              <a:t>03 / 08   NotebookLM CLI outline / notebook 75521ea6-6b9b-47b2-9508-50050d8ab2d5</a:t>
             </a:r>
           </a:p>
         </p:txBody>
@@ -6000,7 +6000,7 @@
               </a:defRPr>
             </a:pPr>
             <a:r>
-              <a:t>NotebookLM sources ready: 36</a:t>
+              <a:t>NotebookLM sources ready: 37</a:t>
             </a:r>
           </a:p>
           <a:p>
@@ -6184,7 +6184,7 @@
                 </a:solidFill>
                 <a:latin typeface="Yu Gothic"/>
               </a:rPr>
-              <a:t>04 / 08   NotebookLM CLI outline / notebook a235db10-d2c5-4ee3-9621-89efbb59e74c</a:t>
+              <a:t>04 / 08   NotebookLM CLI outline / notebook 75521ea6-6b9b-47b2-9508-50050d8ab2d5</a:t>
             </a:r>
           </a:p>
         </p:txBody>
@@ -7393,7 +7393,7 @@
                 </a:solidFill>
                 <a:latin typeface="Yu Gothic"/>
               </a:rPr>
-              <a:t>05 / 08   NotebookLM CLI outline / notebook a235db10-d2c5-4ee3-9621-89efbb59e74c</a:t>
+              <a:t>05 / 08   NotebookLM CLI outline / notebook 75521ea6-6b9b-47b2-9508-50050d8ab2d5</a:t>
             </a:r>
           </a:p>
         </p:txBody>
@@ -8183,7 +8183,7 @@
               </a:defRPr>
             </a:pPr>
             <a:r>
-              <a:t>NotebookLM notebook: a235db10-d2c5-4ee3-9621-89efbb59e74c</a:t>
+              <a:t>NotebookLM notebook: 75521ea6-6b9b-47b2-9508-50050d8ab2d5</a:t>
             </a:r>
           </a:p>
           <a:p>
@@ -8383,7 +8383,7 @@
                 </a:solidFill>
                 <a:latin typeface="Yu Gothic"/>
               </a:rPr>
-              <a:t>06 / 08   NotebookLM CLI outline / notebook a235db10-d2c5-4ee3-9621-89efbb59e74c</a:t>
+              <a:t>06 / 08   NotebookLM CLI outline / notebook 75521ea6-6b9b-47b2-9508-50050d8ab2d5</a:t>
             </a:r>
           </a:p>
         </p:txBody>
@@ -9646,7 +9646,7 @@
                 </a:solidFill>
                 <a:latin typeface="Yu Gothic"/>
               </a:rPr>
-              <a:t>07 / 08   NotebookLM CLI outline / notebook a235db10-d2c5-4ee3-9621-89efbb59e74c</a:t>
+              <a:t>07 / 08   NotebookLM CLI outline / notebook 75521ea6-6b9b-47b2-9508-50050d8ab2d5</a:t>
             </a:r>
           </a:p>
         </p:txBody>
@@ -10750,7 +10750,7 @@
                 </a:solidFill>
                 <a:latin typeface="Yu Gothic"/>
               </a:rPr>
-              <a:t>08 / 08   NotebookLM CLI outline / notebook a235db10-d2c5-4ee3-9621-89efbb59e74c</a:t>
+              <a:t>08 / 08   NotebookLM CLI outline / notebook 75521ea6-6b9b-47b2-9508-50050d8ab2d5</a:t>
             </a:r>
           </a:p>
         </p:txBody>

</xml_diff>

<commit_message>
docs, tsv, release: complete T735_2 production accept test, reschedule subsequent tasks, and resolve task ID conflicts
</commit_message>
<xml_diff>
--- a/exports/knowledge_flow/mighty_skill_bridge_ceo_presentation_2026-06-02.pptx
+++ b/exports/knowledge_flow/mighty_skill_bridge_ceo_presentation_2026-06-02.pptx
@@ -4584,7 +4584,7 @@
                 </a:solidFill>
                 <a:latin typeface="Yu Gothic"/>
               </a:rPr>
-              <a:t>195 tasks</a:t>
+              <a:t>197 tasks</a:t>
             </a:r>
           </a:p>
         </p:txBody>
@@ -6000,7 +6000,7 @@
               </a:defRPr>
             </a:pPr>
             <a:r>
-              <a:t>NotebookLM sources ready: 42</a:t>
+              <a:t>NotebookLM sources ready: 48</a:t>
             </a:r>
           </a:p>
           <a:p>

</xml_diff>

<commit_message>
docs(T788): add Firebase Supabase staging guard
</commit_message>
<xml_diff>
--- a/exports/knowledge_flow/mighty_skill_bridge_ceo_presentation_2026-06-02.pptx
+++ b/exports/knowledge_flow/mighty_skill_bridge_ceo_presentation_2026-06-02.pptx
@@ -3240,7 +3240,7 @@
                 </a:solidFill>
                 <a:latin typeface="Yu Gothic"/>
               </a:rPr>
-              <a:t>01 / 08   NotebookLM CLI outline / notebook 75521ea6-6b9b-47b2-9508-50050d8ab2d5</a:t>
+              <a:t>01 / 08   NotebookLM CLI outline / notebook cd44c4ef-4c46-40b5-ace3-1b6904d29591</a:t>
             </a:r>
           </a:p>
         </p:txBody>
@@ -4134,7 +4134,7 @@
                 </a:solidFill>
                 <a:latin typeface="Yu Gothic"/>
               </a:rPr>
-              <a:t>02 / 08   NotebookLM CLI outline / notebook 75521ea6-6b9b-47b2-9508-50050d8ab2d5</a:t>
+              <a:t>02 / 08   NotebookLM CLI outline / notebook cd44c4ef-4c46-40b5-ace3-1b6904d29591</a:t>
             </a:r>
           </a:p>
         </p:txBody>
@@ -5044,7 +5044,7 @@
                 </a:solidFill>
                 <a:latin typeface="Yu Gothic"/>
               </a:rPr>
-              <a:t>03 / 08   NotebookLM CLI outline / notebook 75521ea6-6b9b-47b2-9508-50050d8ab2d5</a:t>
+              <a:t>03 / 08   NotebookLM CLI outline / notebook cd44c4ef-4c46-40b5-ace3-1b6904d29591</a:t>
             </a:r>
           </a:p>
         </p:txBody>
@@ -6000,7 +6000,7 @@
               </a:defRPr>
             </a:pPr>
             <a:r>
-              <a:t>NotebookLM sources ready: 51</a:t>
+              <a:t>NotebookLM sources ready: 52</a:t>
             </a:r>
           </a:p>
           <a:p>
@@ -6184,7 +6184,7 @@
                 </a:solidFill>
                 <a:latin typeface="Yu Gothic"/>
               </a:rPr>
-              <a:t>04 / 08   NotebookLM CLI outline / notebook 75521ea6-6b9b-47b2-9508-50050d8ab2d5</a:t>
+              <a:t>04 / 08   NotebookLM CLI outline / notebook cd44c4ef-4c46-40b5-ace3-1b6904d29591</a:t>
             </a:r>
           </a:p>
         </p:txBody>
@@ -7393,7 +7393,7 @@
                 </a:solidFill>
                 <a:latin typeface="Yu Gothic"/>
               </a:rPr>
-              <a:t>05 / 08   NotebookLM CLI outline / notebook 75521ea6-6b9b-47b2-9508-50050d8ab2d5</a:t>
+              <a:t>05 / 08   NotebookLM CLI outline / notebook cd44c4ef-4c46-40b5-ace3-1b6904d29591</a:t>
             </a:r>
           </a:p>
         </p:txBody>
@@ -8183,7 +8183,7 @@
               </a:defRPr>
             </a:pPr>
             <a:r>
-              <a:t>NotebookLM notebook: 75521ea6-6b9b-47b2-9508-50050d8ab2d5</a:t>
+              <a:t>NotebookLM notebook: cd44c4ef-4c46-40b5-ace3-1b6904d29591</a:t>
             </a:r>
           </a:p>
           <a:p>
@@ -8383,7 +8383,7 @@
                 </a:solidFill>
                 <a:latin typeface="Yu Gothic"/>
               </a:rPr>
-              <a:t>06 / 08   NotebookLM CLI outline / notebook 75521ea6-6b9b-47b2-9508-50050d8ab2d5</a:t>
+              <a:t>06 / 08   NotebookLM CLI outline / notebook cd44c4ef-4c46-40b5-ace3-1b6904d29591</a:t>
             </a:r>
           </a:p>
         </p:txBody>
@@ -9646,7 +9646,7 @@
                 </a:solidFill>
                 <a:latin typeface="Yu Gothic"/>
               </a:rPr>
-              <a:t>07 / 08   NotebookLM CLI outline / notebook 75521ea6-6b9b-47b2-9508-50050d8ab2d5</a:t>
+              <a:t>07 / 08   NotebookLM CLI outline / notebook cd44c4ef-4c46-40b5-ace3-1b6904d29591</a:t>
             </a:r>
           </a:p>
         </p:txBody>
@@ -10750,7 +10750,7 @@
                 </a:solidFill>
                 <a:latin typeface="Yu Gothic"/>
               </a:rPr>
-              <a:t>08 / 08   NotebookLM CLI outline / notebook 75521ea6-6b9b-47b2-9508-50050d8ab2d5</a:t>
+              <a:t>08 / 08   NotebookLM CLI outline / notebook cd44c4ef-4c46-40b5-ace3-1b6904d29591</a:t>
             </a:r>
           </a:p>
         </p:txBody>

</xml_diff>

<commit_message>
chore(T809): NotebookLM/Drive 同期成果物とカレンダー .ics の再生成
Co-Authored-By: Claude Fable 5 <noreply@anthropic.com>
</commit_message>
<xml_diff>
--- a/exports/knowledge_flow/mighty_skill_bridge_ceo_presentation_2026-06-02.pptx
+++ b/exports/knowledge_flow/mighty_skill_bridge_ceo_presentation_2026-06-02.pptx
@@ -4584,7 +4584,7 @@
                 </a:solidFill>
                 <a:latin typeface="Yu Gothic"/>
               </a:rPr>
-              <a:t>217 tasks</a:t>
+              <a:t>222 tasks</a:t>
             </a:r>
           </a:p>
         </p:txBody>
@@ -6000,7 +6000,7 @@
               </a:defRPr>
             </a:pPr>
             <a:r>
-              <a:t>NotebookLM sources ready: 58</a:t>
+              <a:t>NotebookLM sources ready: 59</a:t>
             </a:r>
           </a:p>
           <a:p>

</xml_diff>

<commit_message>
docs(T740): reconcile domain guide closeout state
</commit_message>
<xml_diff>
--- a/exports/knowledge_flow/mighty_skill_bridge_ceo_presentation_2026-06-02.pptx
+++ b/exports/knowledge_flow/mighty_skill_bridge_ceo_presentation_2026-06-02.pptx
@@ -3240,7 +3240,7 @@
                 </a:solidFill>
                 <a:latin typeface="Yu Gothic"/>
               </a:rPr>
-              <a:t>01 / 08   NotebookLM CLI outline / notebook cd44c4ef-4c46-40b5-ace3-1b6904d29591</a:t>
+              <a:t>01 / 08   NotebookLM CLI outline / notebook 75521ea6-6b9b-47b2-9508-50050d8ab2d5</a:t>
             </a:r>
           </a:p>
         </p:txBody>
@@ -4134,7 +4134,7 @@
                 </a:solidFill>
                 <a:latin typeface="Yu Gothic"/>
               </a:rPr>
-              <a:t>02 / 08   NotebookLM CLI outline / notebook cd44c4ef-4c46-40b5-ace3-1b6904d29591</a:t>
+              <a:t>02 / 08   NotebookLM CLI outline / notebook 75521ea6-6b9b-47b2-9508-50050d8ab2d5</a:t>
             </a:r>
           </a:p>
         </p:txBody>
@@ -4584,7 +4584,7 @@
                 </a:solidFill>
                 <a:latin typeface="Yu Gothic"/>
               </a:rPr>
-              <a:t>222 tasks</a:t>
+              <a:t>225 tasks</a:t>
             </a:r>
           </a:p>
         </p:txBody>
@@ -5044,7 +5044,7 @@
                 </a:solidFill>
                 <a:latin typeface="Yu Gothic"/>
               </a:rPr>
-              <a:t>03 / 08   NotebookLM CLI outline / notebook cd44c4ef-4c46-40b5-ace3-1b6904d29591</a:t>
+              <a:t>03 / 08   NotebookLM CLI outline / notebook 75521ea6-6b9b-47b2-9508-50050d8ab2d5</a:t>
             </a:r>
           </a:p>
         </p:txBody>
@@ -6000,7 +6000,7 @@
               </a:defRPr>
             </a:pPr>
             <a:r>
-              <a:t>NotebookLM sources ready: 59</a:t>
+              <a:t>NotebookLM sources ready: 60</a:t>
             </a:r>
           </a:p>
           <a:p>
@@ -6184,7 +6184,7 @@
                 </a:solidFill>
                 <a:latin typeface="Yu Gothic"/>
               </a:rPr>
-              <a:t>04 / 08   NotebookLM CLI outline / notebook cd44c4ef-4c46-40b5-ace3-1b6904d29591</a:t>
+              <a:t>04 / 08   NotebookLM CLI outline / notebook 75521ea6-6b9b-47b2-9508-50050d8ab2d5</a:t>
             </a:r>
           </a:p>
         </p:txBody>
@@ -7393,7 +7393,7 @@
                 </a:solidFill>
                 <a:latin typeface="Yu Gothic"/>
               </a:rPr>
-              <a:t>05 / 08   NotebookLM CLI outline / notebook cd44c4ef-4c46-40b5-ace3-1b6904d29591</a:t>
+              <a:t>05 / 08   NotebookLM CLI outline / notebook 75521ea6-6b9b-47b2-9508-50050d8ab2d5</a:t>
             </a:r>
           </a:p>
         </p:txBody>
@@ -8183,7 +8183,7 @@
               </a:defRPr>
             </a:pPr>
             <a:r>
-              <a:t>NotebookLM notebook: cd44c4ef-4c46-40b5-ace3-1b6904d29591</a:t>
+              <a:t>NotebookLM notebook: 75521ea6-6b9b-47b2-9508-50050d8ab2d5</a:t>
             </a:r>
           </a:p>
           <a:p>
@@ -8383,7 +8383,7 @@
                 </a:solidFill>
                 <a:latin typeface="Yu Gothic"/>
               </a:rPr>
-              <a:t>06 / 08   NotebookLM CLI outline / notebook cd44c4ef-4c46-40b5-ace3-1b6904d29591</a:t>
+              <a:t>06 / 08   NotebookLM CLI outline / notebook 75521ea6-6b9b-47b2-9508-50050d8ab2d5</a:t>
             </a:r>
           </a:p>
         </p:txBody>
@@ -9646,7 +9646,7 @@
                 </a:solidFill>
                 <a:latin typeface="Yu Gothic"/>
               </a:rPr>
-              <a:t>07 / 08   NotebookLM CLI outline / notebook cd44c4ef-4c46-40b5-ace3-1b6904d29591</a:t>
+              <a:t>07 / 08   NotebookLM CLI outline / notebook 75521ea6-6b9b-47b2-9508-50050d8ab2d5</a:t>
             </a:r>
           </a:p>
         </p:txBody>
@@ -10750,7 +10750,7 @@
                 </a:solidFill>
                 <a:latin typeface="Yu Gothic"/>
               </a:rPr>
-              <a:t>08 / 08   NotebookLM CLI outline / notebook cd44c4ef-4c46-40b5-ace3-1b6904d29591</a:t>
+              <a:t>08 / 08   NotebookLM CLI outline / notebook 75521ea6-6b9b-47b2-9508-50050d8ab2d5</a:t>
             </a:r>
           </a:p>
         </p:txBody>

</xml_diff>

<commit_message>
chore: sync NotebookLM sources after login
</commit_message>
<xml_diff>
--- a/exports/knowledge_flow/mighty_skill_bridge_ceo_presentation_2026-06-02.pptx
+++ b/exports/knowledge_flow/mighty_skill_bridge_ceo_presentation_2026-06-02.pptx
@@ -3240,7 +3240,7 @@
                 </a:solidFill>
                 <a:latin typeface="Yu Gothic"/>
               </a:rPr>
-              <a:t>01 / 08   NotebookLM CLI outline / notebook 75521ea6-6b9b-47b2-9508-50050d8ab2d5</a:t>
+              <a:t>01 / 08   NotebookLM CLI outline / notebook e82f0b43-69aa-474a-9b6c-b67f018696fb</a:t>
             </a:r>
           </a:p>
         </p:txBody>
@@ -4134,7 +4134,7 @@
                 </a:solidFill>
                 <a:latin typeface="Yu Gothic"/>
               </a:rPr>
-              <a:t>02 / 08   NotebookLM CLI outline / notebook 75521ea6-6b9b-47b2-9508-50050d8ab2d5</a:t>
+              <a:t>02 / 08   NotebookLM CLI outline / notebook e82f0b43-69aa-474a-9b6c-b67f018696fb</a:t>
             </a:r>
           </a:p>
         </p:txBody>
@@ -5044,7 +5044,7 @@
                 </a:solidFill>
                 <a:latin typeface="Yu Gothic"/>
               </a:rPr>
-              <a:t>03 / 08   NotebookLM CLI outline / notebook 75521ea6-6b9b-47b2-9508-50050d8ab2d5</a:t>
+              <a:t>03 / 08   NotebookLM CLI outline / notebook e82f0b43-69aa-474a-9b6c-b67f018696fb</a:t>
             </a:r>
           </a:p>
         </p:txBody>
@@ -6184,7 +6184,7 @@
                 </a:solidFill>
                 <a:latin typeface="Yu Gothic"/>
               </a:rPr>
-              <a:t>04 / 08   NotebookLM CLI outline / notebook 75521ea6-6b9b-47b2-9508-50050d8ab2d5</a:t>
+              <a:t>04 / 08   NotebookLM CLI outline / notebook e82f0b43-69aa-474a-9b6c-b67f018696fb</a:t>
             </a:r>
           </a:p>
         </p:txBody>
@@ -7393,7 +7393,7 @@
                 </a:solidFill>
                 <a:latin typeface="Yu Gothic"/>
               </a:rPr>
-              <a:t>05 / 08   NotebookLM CLI outline / notebook 75521ea6-6b9b-47b2-9508-50050d8ab2d5</a:t>
+              <a:t>05 / 08   NotebookLM CLI outline / notebook e82f0b43-69aa-474a-9b6c-b67f018696fb</a:t>
             </a:r>
           </a:p>
         </p:txBody>
@@ -8183,7 +8183,7 @@
               </a:defRPr>
             </a:pPr>
             <a:r>
-              <a:t>NotebookLM notebook: 75521ea6-6b9b-47b2-9508-50050d8ab2d5</a:t>
+              <a:t>NotebookLM notebook: e82f0b43-69aa-474a-9b6c-b67f018696fb</a:t>
             </a:r>
           </a:p>
           <a:p>
@@ -8383,7 +8383,7 @@
                 </a:solidFill>
                 <a:latin typeface="Yu Gothic"/>
               </a:rPr>
-              <a:t>06 / 08   NotebookLM CLI outline / notebook 75521ea6-6b9b-47b2-9508-50050d8ab2d5</a:t>
+              <a:t>06 / 08   NotebookLM CLI outline / notebook e82f0b43-69aa-474a-9b6c-b67f018696fb</a:t>
             </a:r>
           </a:p>
         </p:txBody>
@@ -9646,7 +9646,7 @@
                 </a:solidFill>
                 <a:latin typeface="Yu Gothic"/>
               </a:rPr>
-              <a:t>07 / 08   NotebookLM CLI outline / notebook 75521ea6-6b9b-47b2-9508-50050d8ab2d5</a:t>
+              <a:t>07 / 08   NotebookLM CLI outline / notebook e82f0b43-69aa-474a-9b6c-b67f018696fb</a:t>
             </a:r>
           </a:p>
         </p:txBody>
@@ -10750,7 +10750,7 @@
                 </a:solidFill>
                 <a:latin typeface="Yu Gothic"/>
               </a:rPr>
-              <a:t>08 / 08   NotebookLM CLI outline / notebook 75521ea6-6b9b-47b2-9508-50050d8ab2d5</a:t>
+              <a:t>08 / 08   NotebookLM CLI outline / notebook e82f0b43-69aa-474a-9b6c-b67f018696fb</a:t>
             </a:r>
           </a:p>
         </p:txBody>

</xml_diff>

<commit_message>
docs(T810): add incident postmortem runbook
</commit_message>
<xml_diff>
--- a/exports/knowledge_flow/mighty_skill_bridge_ceo_presentation_2026-06-02.pptx
+++ b/exports/knowledge_flow/mighty_skill_bridge_ceo_presentation_2026-06-02.pptx
@@ -3240,7 +3240,7 @@
                 </a:solidFill>
                 <a:latin typeface="Yu Gothic"/>
               </a:rPr>
-              <a:t>01 / 08   NotebookLM CLI outline / notebook e82f0b43-69aa-474a-9b6c-b67f018696fb</a:t>
+              <a:t>01 / 08   NotebookLM CLI outline / notebook 75521ea6-6b9b-47b2-9508-50050d8ab2d5</a:t>
             </a:r>
           </a:p>
         </p:txBody>
@@ -4134,7 +4134,7 @@
                 </a:solidFill>
                 <a:latin typeface="Yu Gothic"/>
               </a:rPr>
-              <a:t>02 / 08   NotebookLM CLI outline / notebook e82f0b43-69aa-474a-9b6c-b67f018696fb</a:t>
+              <a:t>02 / 08   NotebookLM CLI outline / notebook 75521ea6-6b9b-47b2-9508-50050d8ab2d5</a:t>
             </a:r>
           </a:p>
         </p:txBody>
@@ -5044,7 +5044,7 @@
                 </a:solidFill>
                 <a:latin typeface="Yu Gothic"/>
               </a:rPr>
-              <a:t>03 / 08   NotebookLM CLI outline / notebook e82f0b43-69aa-474a-9b6c-b67f018696fb</a:t>
+              <a:t>03 / 08   NotebookLM CLI outline / notebook 75521ea6-6b9b-47b2-9508-50050d8ab2d5</a:t>
             </a:r>
           </a:p>
         </p:txBody>
@@ -6000,7 +6000,7 @@
               </a:defRPr>
             </a:pPr>
             <a:r>
-              <a:t>NotebookLM sources ready: 62</a:t>
+              <a:t>NotebookLM sources ready: 64</a:t>
             </a:r>
           </a:p>
           <a:p>
@@ -6184,7 +6184,7 @@
                 </a:solidFill>
                 <a:latin typeface="Yu Gothic"/>
               </a:rPr>
-              <a:t>04 / 08   NotebookLM CLI outline / notebook e82f0b43-69aa-474a-9b6c-b67f018696fb</a:t>
+              <a:t>04 / 08   NotebookLM CLI outline / notebook 75521ea6-6b9b-47b2-9508-50050d8ab2d5</a:t>
             </a:r>
           </a:p>
         </p:txBody>
@@ -7393,7 +7393,7 @@
                 </a:solidFill>
                 <a:latin typeface="Yu Gothic"/>
               </a:rPr>
-              <a:t>05 / 08   NotebookLM CLI outline / notebook e82f0b43-69aa-474a-9b6c-b67f018696fb</a:t>
+              <a:t>05 / 08   NotebookLM CLI outline / notebook 75521ea6-6b9b-47b2-9508-50050d8ab2d5</a:t>
             </a:r>
           </a:p>
         </p:txBody>
@@ -8183,7 +8183,7 @@
               </a:defRPr>
             </a:pPr>
             <a:r>
-              <a:t>NotebookLM notebook: e82f0b43-69aa-474a-9b6c-b67f018696fb</a:t>
+              <a:t>NotebookLM notebook: 75521ea6-6b9b-47b2-9508-50050d8ab2d5</a:t>
             </a:r>
           </a:p>
           <a:p>
@@ -8383,7 +8383,7 @@
                 </a:solidFill>
                 <a:latin typeface="Yu Gothic"/>
               </a:rPr>
-              <a:t>06 / 08   NotebookLM CLI outline / notebook e82f0b43-69aa-474a-9b6c-b67f018696fb</a:t>
+              <a:t>06 / 08   NotebookLM CLI outline / notebook 75521ea6-6b9b-47b2-9508-50050d8ab2d5</a:t>
             </a:r>
           </a:p>
         </p:txBody>
@@ -9646,7 +9646,7 @@
                 </a:solidFill>
                 <a:latin typeface="Yu Gothic"/>
               </a:rPr>
-              <a:t>07 / 08   NotebookLM CLI outline / notebook e82f0b43-69aa-474a-9b6c-b67f018696fb</a:t>
+              <a:t>07 / 08   NotebookLM CLI outline / notebook 75521ea6-6b9b-47b2-9508-50050d8ab2d5</a:t>
             </a:r>
           </a:p>
         </p:txBody>
@@ -10750,7 +10750,7 @@
                 </a:solidFill>
                 <a:latin typeface="Yu Gothic"/>
               </a:rPr>
-              <a:t>08 / 08   NotebookLM CLI outline / notebook e82f0b43-69aa-474a-9b6c-b67f018696fb</a:t>
+              <a:t>08 / 08   NotebookLM CLI outline / notebook 75521ea6-6b9b-47b2-9508-50050d8ab2d5</a:t>
             </a:r>
           </a:p>
         </p:txBody>

</xml_diff>

<commit_message>
chore(T748): add runtime log rotation operations
</commit_message>
<xml_diff>
--- a/exports/knowledge_flow/mighty_skill_bridge_ceo_presentation_2026-06-02.pptx
+++ b/exports/knowledge_flow/mighty_skill_bridge_ceo_presentation_2026-06-02.pptx
@@ -3240,7 +3240,7 @@
                 </a:solidFill>
                 <a:latin typeface="Yu Gothic"/>
               </a:rPr>
-              <a:t>01 / 08   NotebookLM CLI outline / notebook 75521ea6-6b9b-47b2-9508-50050d8ab2d5</a:t>
+              <a:t>01 / 08   NotebookLM CLI outline / notebook 2c7c4a2d-2731-4c8f-8136-4c41daa7b7b3</a:t>
             </a:r>
           </a:p>
         </p:txBody>
@@ -4134,7 +4134,7 @@
                 </a:solidFill>
                 <a:latin typeface="Yu Gothic"/>
               </a:rPr>
-              <a:t>02 / 08   NotebookLM CLI outline / notebook 75521ea6-6b9b-47b2-9508-50050d8ab2d5</a:t>
+              <a:t>02 / 08   NotebookLM CLI outline / notebook 2c7c4a2d-2731-4c8f-8136-4c41daa7b7b3</a:t>
             </a:r>
           </a:p>
         </p:txBody>
@@ -5044,7 +5044,7 @@
                 </a:solidFill>
                 <a:latin typeface="Yu Gothic"/>
               </a:rPr>
-              <a:t>03 / 08   NotebookLM CLI outline / notebook 75521ea6-6b9b-47b2-9508-50050d8ab2d5</a:t>
+              <a:t>03 / 08   NotebookLM CLI outline / notebook 2c7c4a2d-2731-4c8f-8136-4c41daa7b7b3</a:t>
             </a:r>
           </a:p>
         </p:txBody>
@@ -6000,7 +6000,7 @@
               </a:defRPr>
             </a:pPr>
             <a:r>
-              <a:t>NotebookLM sources ready: 64</a:t>
+              <a:t>NotebookLM sources ready: 65</a:t>
             </a:r>
           </a:p>
           <a:p>
@@ -6184,7 +6184,7 @@
                 </a:solidFill>
                 <a:latin typeface="Yu Gothic"/>
               </a:rPr>
-              <a:t>04 / 08   NotebookLM CLI outline / notebook 75521ea6-6b9b-47b2-9508-50050d8ab2d5</a:t>
+              <a:t>04 / 08   NotebookLM CLI outline / notebook 2c7c4a2d-2731-4c8f-8136-4c41daa7b7b3</a:t>
             </a:r>
           </a:p>
         </p:txBody>
@@ -7393,7 +7393,7 @@
                 </a:solidFill>
                 <a:latin typeface="Yu Gothic"/>
               </a:rPr>
-              <a:t>05 / 08   NotebookLM CLI outline / notebook 75521ea6-6b9b-47b2-9508-50050d8ab2d5</a:t>
+              <a:t>05 / 08   NotebookLM CLI outline / notebook 2c7c4a2d-2731-4c8f-8136-4c41daa7b7b3</a:t>
             </a:r>
           </a:p>
         </p:txBody>
@@ -8183,7 +8183,7 @@
               </a:defRPr>
             </a:pPr>
             <a:r>
-              <a:t>NotebookLM notebook: 75521ea6-6b9b-47b2-9508-50050d8ab2d5</a:t>
+              <a:t>NotebookLM notebook: 2c7c4a2d-2731-4c8f-8136-4c41daa7b7b3</a:t>
             </a:r>
           </a:p>
           <a:p>
@@ -8383,7 +8383,7 @@
                 </a:solidFill>
                 <a:latin typeface="Yu Gothic"/>
               </a:rPr>
-              <a:t>06 / 08   NotebookLM CLI outline / notebook 75521ea6-6b9b-47b2-9508-50050d8ab2d5</a:t>
+              <a:t>06 / 08   NotebookLM CLI outline / notebook 2c7c4a2d-2731-4c8f-8136-4c41daa7b7b3</a:t>
             </a:r>
           </a:p>
         </p:txBody>
@@ -9646,7 +9646,7 @@
                 </a:solidFill>
                 <a:latin typeface="Yu Gothic"/>
               </a:rPr>
-              <a:t>07 / 08   NotebookLM CLI outline / notebook 75521ea6-6b9b-47b2-9508-50050d8ab2d5</a:t>
+              <a:t>07 / 08   NotebookLM CLI outline / notebook 2c7c4a2d-2731-4c8f-8136-4c41daa7b7b3</a:t>
             </a:r>
           </a:p>
         </p:txBody>
@@ -10750,7 +10750,7 @@
                 </a:solidFill>
                 <a:latin typeface="Yu Gothic"/>
               </a:rPr>
-              <a:t>08 / 08   NotebookLM CLI outline / notebook 75521ea6-6b9b-47b2-9508-50050d8ab2d5</a:t>
+              <a:t>08 / 08   NotebookLM CLI outline / notebook 2c7c4a2d-2731-4c8f-8136-4c41daa7b7b3</a:t>
             </a:r>
           </a:p>
         </p:txBody>

</xml_diff>

<commit_message>
chore(T753): add API rate limiting guard
</commit_message>
<xml_diff>
--- a/exports/knowledge_flow/mighty_skill_bridge_ceo_presentation_2026-06-02.pptx
+++ b/exports/knowledge_flow/mighty_skill_bridge_ceo_presentation_2026-06-02.pptx
@@ -3240,7 +3240,7 @@
                 </a:solidFill>
                 <a:latin typeface="Yu Gothic"/>
               </a:rPr>
-              <a:t>01 / 08   NotebookLM CLI outline / notebook 2c7c4a2d-2731-4c8f-8136-4c41daa7b7b3</a:t>
+              <a:t>01 / 08   NotebookLM CLI outline / notebook 75521ea6-6b9b-47b2-9508-50050d8ab2d5</a:t>
             </a:r>
           </a:p>
         </p:txBody>
@@ -4134,7 +4134,7 @@
                 </a:solidFill>
                 <a:latin typeface="Yu Gothic"/>
               </a:rPr>
-              <a:t>02 / 08   NotebookLM CLI outline / notebook 2c7c4a2d-2731-4c8f-8136-4c41daa7b7b3</a:t>
+              <a:t>02 / 08   NotebookLM CLI outline / notebook 75521ea6-6b9b-47b2-9508-50050d8ab2d5</a:t>
             </a:r>
           </a:p>
         </p:txBody>
@@ -5044,7 +5044,7 @@
                 </a:solidFill>
                 <a:latin typeface="Yu Gothic"/>
               </a:rPr>
-              <a:t>03 / 08   NotebookLM CLI outline / notebook 2c7c4a2d-2731-4c8f-8136-4c41daa7b7b3</a:t>
+              <a:t>03 / 08   NotebookLM CLI outline / notebook 75521ea6-6b9b-47b2-9508-50050d8ab2d5</a:t>
             </a:r>
           </a:p>
         </p:txBody>
@@ -6000,7 +6000,7 @@
               </a:defRPr>
             </a:pPr>
             <a:r>
-              <a:t>NotebookLM sources ready: 68</a:t>
+              <a:t>NotebookLM sources ready: 69</a:t>
             </a:r>
           </a:p>
           <a:p>
@@ -6184,7 +6184,7 @@
                 </a:solidFill>
                 <a:latin typeface="Yu Gothic"/>
               </a:rPr>
-              <a:t>04 / 08   NotebookLM CLI outline / notebook 2c7c4a2d-2731-4c8f-8136-4c41daa7b7b3</a:t>
+              <a:t>04 / 08   NotebookLM CLI outline / notebook 75521ea6-6b9b-47b2-9508-50050d8ab2d5</a:t>
             </a:r>
           </a:p>
         </p:txBody>
@@ -7393,7 +7393,7 @@
                 </a:solidFill>
                 <a:latin typeface="Yu Gothic"/>
               </a:rPr>
-              <a:t>05 / 08   NotebookLM CLI outline / notebook 2c7c4a2d-2731-4c8f-8136-4c41daa7b7b3</a:t>
+              <a:t>05 / 08   NotebookLM CLI outline / notebook 75521ea6-6b9b-47b2-9508-50050d8ab2d5</a:t>
             </a:r>
           </a:p>
         </p:txBody>
@@ -8183,7 +8183,7 @@
               </a:defRPr>
             </a:pPr>
             <a:r>
-              <a:t>NotebookLM notebook: 2c7c4a2d-2731-4c8f-8136-4c41daa7b7b3</a:t>
+              <a:t>NotebookLM notebook: 75521ea6-6b9b-47b2-9508-50050d8ab2d5</a:t>
             </a:r>
           </a:p>
           <a:p>
@@ -8383,7 +8383,7 @@
                 </a:solidFill>
                 <a:latin typeface="Yu Gothic"/>
               </a:rPr>
-              <a:t>06 / 08   NotebookLM CLI outline / notebook 2c7c4a2d-2731-4c8f-8136-4c41daa7b7b3</a:t>
+              <a:t>06 / 08   NotebookLM CLI outline / notebook 75521ea6-6b9b-47b2-9508-50050d8ab2d5</a:t>
             </a:r>
           </a:p>
         </p:txBody>
@@ -9646,7 +9646,7 @@
                 </a:solidFill>
                 <a:latin typeface="Yu Gothic"/>
               </a:rPr>
-              <a:t>07 / 08   NotebookLM CLI outline / notebook 2c7c4a2d-2731-4c8f-8136-4c41daa7b7b3</a:t>
+              <a:t>07 / 08   NotebookLM CLI outline / notebook 75521ea6-6b9b-47b2-9508-50050d8ab2d5</a:t>
             </a:r>
           </a:p>
         </p:txBody>
@@ -10750,7 +10750,7 @@
                 </a:solidFill>
                 <a:latin typeface="Yu Gothic"/>
               </a:rPr>
-              <a:t>08 / 08   NotebookLM CLI outline / notebook 2c7c4a2d-2731-4c8f-8136-4c41daa7b7b3</a:t>
+              <a:t>08 / 08   NotebookLM CLI outline / notebook 75521ea6-6b9b-47b2-9508-50050d8ab2d5</a:t>
             </a:r>
           </a:p>
         </p:txBody>

</xml_diff>

<commit_message>
chore(T760): add local emulator stack validation
</commit_message>
<xml_diff>
--- a/exports/knowledge_flow/mighty_skill_bridge_ceo_presentation_2026-06-02.pptx
+++ b/exports/knowledge_flow/mighty_skill_bridge_ceo_presentation_2026-06-02.pptx
@@ -4584,7 +4584,7 @@
                 </a:solidFill>
                 <a:latin typeface="Yu Gothic"/>
               </a:rPr>
-              <a:t>225 tasks</a:t>
+              <a:t>226 tasks</a:t>
             </a:r>
           </a:p>
         </p:txBody>
@@ -6000,7 +6000,7 @@
               </a:defRPr>
             </a:pPr>
             <a:r>
-              <a:t>NotebookLM sources ready: 73</a:t>
+              <a:t>NotebookLM sources ready: 74</a:t>
             </a:r>
           </a:p>
           <a:p>

</xml_diff>

<commit_message>
docs(T817): reflect 6/17 meeting and prioritize sales email matching
</commit_message>
<xml_diff>
--- a/exports/knowledge_flow/mighty_skill_bridge_ceo_presentation_2026-06-02.pptx
+++ b/exports/knowledge_flow/mighty_skill_bridge_ceo_presentation_2026-06-02.pptx
@@ -4584,7 +4584,7 @@
                 </a:solidFill>
                 <a:latin typeface="Yu Gothic"/>
               </a:rPr>
-              <a:t>226 tasks</a:t>
+              <a:t>239 tasks</a:t>
             </a:r>
           </a:p>
         </p:txBody>
@@ -6000,7 +6000,7 @@
               </a:defRPr>
             </a:pPr>
             <a:r>
-              <a:t>NotebookLM sources ready: 80</a:t>
+              <a:t>NotebookLM sources ready: 81</a:t>
             </a:r>
           </a:p>
           <a:p>

</xml_diff>

<commit_message>
docs(sync): update knowledge flow and presentation metadata
</commit_message>
<xml_diff>
--- a/exports/knowledge_flow/mighty_skill_bridge_ceo_presentation_2026-06-02.pptx
+++ b/exports/knowledge_flow/mighty_skill_bridge_ceo_presentation_2026-06-02.pptx
@@ -3240,7 +3240,7 @@
                 </a:solidFill>
                 <a:latin typeface="Yu Gothic"/>
               </a:rPr>
-              <a:t>01 / 08   NotebookLM CLI outline / notebook 75521ea6-6b9b-47b2-9508-50050d8ab2d5</a:t>
+              <a:t>01 / 08   NotebookLM CLI outline / notebook 56932988-812c-412e-94f4-4878953d20a1</a:t>
             </a:r>
           </a:p>
         </p:txBody>
@@ -4134,7 +4134,7 @@
                 </a:solidFill>
                 <a:latin typeface="Yu Gothic"/>
               </a:rPr>
-              <a:t>02 / 08   NotebookLM CLI outline / notebook 75521ea6-6b9b-47b2-9508-50050d8ab2d5</a:t>
+              <a:t>02 / 08   NotebookLM CLI outline / notebook 56932988-812c-412e-94f4-4878953d20a1</a:t>
             </a:r>
           </a:p>
         </p:txBody>
@@ -5044,7 +5044,7 @@
                 </a:solidFill>
                 <a:latin typeface="Yu Gothic"/>
               </a:rPr>
-              <a:t>03 / 08   NotebookLM CLI outline / notebook 75521ea6-6b9b-47b2-9508-50050d8ab2d5</a:t>
+              <a:t>03 / 08   NotebookLM CLI outline / notebook 56932988-812c-412e-94f4-4878953d20a1</a:t>
             </a:r>
           </a:p>
         </p:txBody>
@@ -6000,7 +6000,7 @@
               </a:defRPr>
             </a:pPr>
             <a:r>
-              <a:t>NotebookLM sources ready: 81</a:t>
+              <a:t>NotebookLM sources ready: 82</a:t>
             </a:r>
           </a:p>
           <a:p>
@@ -6184,7 +6184,7 @@
                 </a:solidFill>
                 <a:latin typeface="Yu Gothic"/>
               </a:rPr>
-              <a:t>04 / 08   NotebookLM CLI outline / notebook 75521ea6-6b9b-47b2-9508-50050d8ab2d5</a:t>
+              <a:t>04 / 08   NotebookLM CLI outline / notebook 56932988-812c-412e-94f4-4878953d20a1</a:t>
             </a:r>
           </a:p>
         </p:txBody>
@@ -7393,7 +7393,7 @@
                 </a:solidFill>
                 <a:latin typeface="Yu Gothic"/>
               </a:rPr>
-              <a:t>05 / 08   NotebookLM CLI outline / notebook 75521ea6-6b9b-47b2-9508-50050d8ab2d5</a:t>
+              <a:t>05 / 08   NotebookLM CLI outline / notebook 56932988-812c-412e-94f4-4878953d20a1</a:t>
             </a:r>
           </a:p>
         </p:txBody>
@@ -8183,7 +8183,7 @@
               </a:defRPr>
             </a:pPr>
             <a:r>
-              <a:t>NotebookLM notebook: 75521ea6-6b9b-47b2-9508-50050d8ab2d5</a:t>
+              <a:t>NotebookLM notebook: 56932988-812c-412e-94f4-4878953d20a1</a:t>
             </a:r>
           </a:p>
           <a:p>
@@ -8383,7 +8383,7 @@
                 </a:solidFill>
                 <a:latin typeface="Yu Gothic"/>
               </a:rPr>
-              <a:t>06 / 08   NotebookLM CLI outline / notebook 75521ea6-6b9b-47b2-9508-50050d8ab2d5</a:t>
+              <a:t>06 / 08   NotebookLM CLI outline / notebook 56932988-812c-412e-94f4-4878953d20a1</a:t>
             </a:r>
           </a:p>
         </p:txBody>
@@ -9646,7 +9646,7 @@
                 </a:solidFill>
                 <a:latin typeface="Yu Gothic"/>
               </a:rPr>
-              <a:t>07 / 08   NotebookLM CLI outline / notebook 75521ea6-6b9b-47b2-9508-50050d8ab2d5</a:t>
+              <a:t>07 / 08   NotebookLM CLI outline / notebook 56932988-812c-412e-94f4-4878953d20a1</a:t>
             </a:r>
           </a:p>
         </p:txBody>
@@ -10750,7 +10750,7 @@
                 </a:solidFill>
                 <a:latin typeface="Yu Gothic"/>
               </a:rPr>
-              <a:t>08 / 08   NotebookLM CLI outline / notebook 75521ea6-6b9b-47b2-9508-50050d8ab2d5</a:t>
+              <a:t>08 / 08   NotebookLM CLI outline / notebook 56932988-812c-412e-94f4-4878953d20a1</a:t>
             </a:r>
           </a:p>
         </p:txBody>

</xml_diff>

<commit_message>
fix: resolve mobile slideshow 404 error and sync WBS/trackers
</commit_message>
<xml_diff>
--- a/exports/knowledge_flow/mighty_skill_bridge_ceo_presentation_2026-06-02.pptx
+++ b/exports/knowledge_flow/mighty_skill_bridge_ceo_presentation_2026-06-02.pptx
@@ -3240,7 +3240,7 @@
                 </a:solidFill>
                 <a:latin typeface="Yu Gothic"/>
               </a:rPr>
-              <a:t>01 / 08   NotebookLM CLI outline / notebook 56932988-812c-412e-94f4-4878953d20a1</a:t>
+              <a:t>01 / 08   NotebookLM CLI outline / notebook 75521ea6-6b9b-47b2-9508-50050d8ab2d5</a:t>
             </a:r>
           </a:p>
         </p:txBody>
@@ -4134,7 +4134,7 @@
                 </a:solidFill>
                 <a:latin typeface="Yu Gothic"/>
               </a:rPr>
-              <a:t>02 / 08   NotebookLM CLI outline / notebook 56932988-812c-412e-94f4-4878953d20a1</a:t>
+              <a:t>02 / 08   NotebookLM CLI outline / notebook 75521ea6-6b9b-47b2-9508-50050d8ab2d5</a:t>
             </a:r>
           </a:p>
         </p:txBody>
@@ -4584,7 +4584,7 @@
                 </a:solidFill>
                 <a:latin typeface="Yu Gothic"/>
               </a:rPr>
-              <a:t>240 tasks</a:t>
+              <a:t>241 tasks</a:t>
             </a:r>
           </a:p>
         </p:txBody>
@@ -5044,7 +5044,7 @@
                 </a:solidFill>
                 <a:latin typeface="Yu Gothic"/>
               </a:rPr>
-              <a:t>03 / 08   NotebookLM CLI outline / notebook 56932988-812c-412e-94f4-4878953d20a1</a:t>
+              <a:t>03 / 08   NotebookLM CLI outline / notebook 75521ea6-6b9b-47b2-9508-50050d8ab2d5</a:t>
             </a:r>
           </a:p>
         </p:txBody>
@@ -6000,7 +6000,7 @@
               </a:defRPr>
             </a:pPr>
             <a:r>
-              <a:t>NotebookLM sources ready: 82</a:t>
+              <a:t>NotebookLM sources ready: 83</a:t>
             </a:r>
           </a:p>
           <a:p>
@@ -6184,7 +6184,7 @@
                 </a:solidFill>
                 <a:latin typeface="Yu Gothic"/>
               </a:rPr>
-              <a:t>04 / 08   NotebookLM CLI outline / notebook 56932988-812c-412e-94f4-4878953d20a1</a:t>
+              <a:t>04 / 08   NotebookLM CLI outline / notebook 75521ea6-6b9b-47b2-9508-50050d8ab2d5</a:t>
             </a:r>
           </a:p>
         </p:txBody>
@@ -7393,7 +7393,7 @@
                 </a:solidFill>
                 <a:latin typeface="Yu Gothic"/>
               </a:rPr>
-              <a:t>05 / 08   NotebookLM CLI outline / notebook 56932988-812c-412e-94f4-4878953d20a1</a:t>
+              <a:t>05 / 08   NotebookLM CLI outline / notebook 75521ea6-6b9b-47b2-9508-50050d8ab2d5</a:t>
             </a:r>
           </a:p>
         </p:txBody>
@@ -8183,7 +8183,7 @@
               </a:defRPr>
             </a:pPr>
             <a:r>
-              <a:t>NotebookLM notebook: 56932988-812c-412e-94f4-4878953d20a1</a:t>
+              <a:t>NotebookLM notebook: 75521ea6-6b9b-47b2-9508-50050d8ab2d5</a:t>
             </a:r>
           </a:p>
           <a:p>
@@ -8383,7 +8383,7 @@
                 </a:solidFill>
                 <a:latin typeface="Yu Gothic"/>
               </a:rPr>
-              <a:t>06 / 08   NotebookLM CLI outline / notebook 56932988-812c-412e-94f4-4878953d20a1</a:t>
+              <a:t>06 / 08   NotebookLM CLI outline / notebook 75521ea6-6b9b-47b2-9508-50050d8ab2d5</a:t>
             </a:r>
           </a:p>
         </p:txBody>
@@ -9646,7 +9646,7 @@
                 </a:solidFill>
                 <a:latin typeface="Yu Gothic"/>
               </a:rPr>
-              <a:t>07 / 08   NotebookLM CLI outline / notebook 56932988-812c-412e-94f4-4878953d20a1</a:t>
+              <a:t>07 / 08   NotebookLM CLI outline / notebook 75521ea6-6b9b-47b2-9508-50050d8ab2d5</a:t>
             </a:r>
           </a:p>
         </p:txBody>
@@ -10750,7 +10750,7 @@
                 </a:solidFill>
                 <a:latin typeface="Yu Gothic"/>
               </a:rPr>
-              <a:t>08 / 08   NotebookLM CLI outline / notebook 56932988-812c-412e-94f4-4878953d20a1</a:t>
+              <a:t>08 / 08   NotebookLM CLI outline / notebook 75521ea6-6b9b-47b2-9508-50050d8ab2d5</a:t>
             </a:r>
           </a:p>
         </p:txBody>

</xml_diff>

<commit_message>
docs(T818): prepare company account migration runbook
</commit_message>
<xml_diff>
--- a/exports/knowledge_flow/mighty_skill_bridge_ceo_presentation_2026-06-02.pptx
+++ b/exports/knowledge_flow/mighty_skill_bridge_ceo_presentation_2026-06-02.pptx
@@ -3240,7 +3240,7 @@
                 </a:solidFill>
                 <a:latin typeface="Yu Gothic"/>
               </a:rPr>
-              <a:t>01 / 08   NotebookLM CLI outline / notebook 75521ea6-6b9b-47b2-9508-50050d8ab2d5</a:t>
+              <a:t>01 / 08   NotebookLM CLI outline / notebook fd58e18d-1c62-43c7-9425-0e708879ec25</a:t>
             </a:r>
           </a:p>
         </p:txBody>
@@ -4134,7 +4134,7 @@
                 </a:solidFill>
                 <a:latin typeface="Yu Gothic"/>
               </a:rPr>
-              <a:t>02 / 08   NotebookLM CLI outline / notebook 75521ea6-6b9b-47b2-9508-50050d8ab2d5</a:t>
+              <a:t>02 / 08   NotebookLM CLI outline / notebook fd58e18d-1c62-43c7-9425-0e708879ec25</a:t>
             </a:r>
           </a:p>
         </p:txBody>
@@ -4584,7 +4584,7 @@
                 </a:solidFill>
                 <a:latin typeface="Yu Gothic"/>
               </a:rPr>
-              <a:t>241 tasks</a:t>
+              <a:t>242 tasks</a:t>
             </a:r>
           </a:p>
         </p:txBody>
@@ -5044,7 +5044,7 @@
                 </a:solidFill>
                 <a:latin typeface="Yu Gothic"/>
               </a:rPr>
-              <a:t>03 / 08   NotebookLM CLI outline / notebook 75521ea6-6b9b-47b2-9508-50050d8ab2d5</a:t>
+              <a:t>03 / 08   NotebookLM CLI outline / notebook fd58e18d-1c62-43c7-9425-0e708879ec25</a:t>
             </a:r>
           </a:p>
         </p:txBody>
@@ -6000,7 +6000,7 @@
               </a:defRPr>
             </a:pPr>
             <a:r>
-              <a:t>NotebookLM sources ready: 85</a:t>
+              <a:t>NotebookLM sources ready: 86</a:t>
             </a:r>
           </a:p>
           <a:p>
@@ -6184,7 +6184,7 @@
                 </a:solidFill>
                 <a:latin typeface="Yu Gothic"/>
               </a:rPr>
-              <a:t>04 / 08   NotebookLM CLI outline / notebook 75521ea6-6b9b-47b2-9508-50050d8ab2d5</a:t>
+              <a:t>04 / 08   NotebookLM CLI outline / notebook fd58e18d-1c62-43c7-9425-0e708879ec25</a:t>
             </a:r>
           </a:p>
         </p:txBody>
@@ -7393,7 +7393,7 @@
                 </a:solidFill>
                 <a:latin typeface="Yu Gothic"/>
               </a:rPr>
-              <a:t>05 / 08   NotebookLM CLI outline / notebook 75521ea6-6b9b-47b2-9508-50050d8ab2d5</a:t>
+              <a:t>05 / 08   NotebookLM CLI outline / notebook fd58e18d-1c62-43c7-9425-0e708879ec25</a:t>
             </a:r>
           </a:p>
         </p:txBody>
@@ -8183,7 +8183,7 @@
               </a:defRPr>
             </a:pPr>
             <a:r>
-              <a:t>NotebookLM notebook: 75521ea6-6b9b-47b2-9508-50050d8ab2d5</a:t>
+              <a:t>NotebookLM notebook: fd58e18d-1c62-43c7-9425-0e708879ec25</a:t>
             </a:r>
           </a:p>
           <a:p>
@@ -8383,7 +8383,7 @@
                 </a:solidFill>
                 <a:latin typeface="Yu Gothic"/>
               </a:rPr>
-              <a:t>06 / 08   NotebookLM CLI outline / notebook 75521ea6-6b9b-47b2-9508-50050d8ab2d5</a:t>
+              <a:t>06 / 08   NotebookLM CLI outline / notebook fd58e18d-1c62-43c7-9425-0e708879ec25</a:t>
             </a:r>
           </a:p>
         </p:txBody>
@@ -9646,7 +9646,7 @@
                 </a:solidFill>
                 <a:latin typeface="Yu Gothic"/>
               </a:rPr>
-              <a:t>07 / 08   NotebookLM CLI outline / notebook 75521ea6-6b9b-47b2-9508-50050d8ab2d5</a:t>
+              <a:t>07 / 08   NotebookLM CLI outline / notebook fd58e18d-1c62-43c7-9425-0e708879ec25</a:t>
             </a:r>
           </a:p>
         </p:txBody>
@@ -10750,7 +10750,7 @@
                 </a:solidFill>
                 <a:latin typeface="Yu Gothic"/>
               </a:rPr>
-              <a:t>08 / 08   NotebookLM CLI outline / notebook 75521ea6-6b9b-47b2-9508-50050d8ab2d5</a:t>
+              <a:t>08 / 08   NotebookLM CLI outline / notebook fd58e18d-1c62-43c7-9425-0e708879ec25</a:t>
             </a:r>
           </a:p>
         </p:txBody>

</xml_diff>

<commit_message>
feat(T781): add user data self-export PoC
</commit_message>
<xml_diff>
--- a/exports/knowledge_flow/mighty_skill_bridge_ceo_presentation_2026-06-02.pptx
+++ b/exports/knowledge_flow/mighty_skill_bridge_ceo_presentation_2026-06-02.pptx
@@ -3240,7 +3240,7 @@
                 </a:solidFill>
                 <a:latin typeface="Yu Gothic"/>
               </a:rPr>
-              <a:t>01 / 08   NotebookLM CLI outline / notebook fd58e18d-1c62-43c7-9425-0e708879ec25</a:t>
+              <a:t>01 / 08   NotebookLM CLI outline / notebook 75521ea6-6b9b-47b2-9508-50050d8ab2d5</a:t>
             </a:r>
           </a:p>
         </p:txBody>
@@ -4134,7 +4134,7 @@
                 </a:solidFill>
                 <a:latin typeface="Yu Gothic"/>
               </a:rPr>
-              <a:t>02 / 08   NotebookLM CLI outline / notebook fd58e18d-1c62-43c7-9425-0e708879ec25</a:t>
+              <a:t>02 / 08   NotebookLM CLI outline / notebook 75521ea6-6b9b-47b2-9508-50050d8ab2d5</a:t>
             </a:r>
           </a:p>
         </p:txBody>
@@ -5044,7 +5044,7 @@
                 </a:solidFill>
                 <a:latin typeface="Yu Gothic"/>
               </a:rPr>
-              <a:t>03 / 08   NotebookLM CLI outline / notebook fd58e18d-1c62-43c7-9425-0e708879ec25</a:t>
+              <a:t>03 / 08   NotebookLM CLI outline / notebook 75521ea6-6b9b-47b2-9508-50050d8ab2d5</a:t>
             </a:r>
           </a:p>
         </p:txBody>
@@ -6000,7 +6000,7 @@
               </a:defRPr>
             </a:pPr>
             <a:r>
-              <a:t>NotebookLM sources ready: 86</a:t>
+              <a:t>NotebookLM sources ready: 89</a:t>
             </a:r>
           </a:p>
           <a:p>
@@ -6184,7 +6184,7 @@
                 </a:solidFill>
                 <a:latin typeface="Yu Gothic"/>
               </a:rPr>
-              <a:t>04 / 08   NotebookLM CLI outline / notebook fd58e18d-1c62-43c7-9425-0e708879ec25</a:t>
+              <a:t>04 / 08   NotebookLM CLI outline / notebook 75521ea6-6b9b-47b2-9508-50050d8ab2d5</a:t>
             </a:r>
           </a:p>
         </p:txBody>
@@ -7393,7 +7393,7 @@
                 </a:solidFill>
                 <a:latin typeface="Yu Gothic"/>
               </a:rPr>
-              <a:t>05 / 08   NotebookLM CLI outline / notebook fd58e18d-1c62-43c7-9425-0e708879ec25</a:t>
+              <a:t>05 / 08   NotebookLM CLI outline / notebook 75521ea6-6b9b-47b2-9508-50050d8ab2d5</a:t>
             </a:r>
           </a:p>
         </p:txBody>
@@ -8183,7 +8183,7 @@
               </a:defRPr>
             </a:pPr>
             <a:r>
-              <a:t>NotebookLM notebook: fd58e18d-1c62-43c7-9425-0e708879ec25</a:t>
+              <a:t>NotebookLM notebook: 75521ea6-6b9b-47b2-9508-50050d8ab2d5</a:t>
             </a:r>
           </a:p>
           <a:p>
@@ -8383,7 +8383,7 @@
                 </a:solidFill>
                 <a:latin typeface="Yu Gothic"/>
               </a:rPr>
-              <a:t>06 / 08   NotebookLM CLI outline / notebook fd58e18d-1c62-43c7-9425-0e708879ec25</a:t>
+              <a:t>06 / 08   NotebookLM CLI outline / notebook 75521ea6-6b9b-47b2-9508-50050d8ab2d5</a:t>
             </a:r>
           </a:p>
         </p:txBody>
@@ -9646,7 +9646,7 @@
                 </a:solidFill>
                 <a:latin typeface="Yu Gothic"/>
               </a:rPr>
-              <a:t>07 / 08   NotebookLM CLI outline / notebook fd58e18d-1c62-43c7-9425-0e708879ec25</a:t>
+              <a:t>07 / 08   NotebookLM CLI outline / notebook 75521ea6-6b9b-47b2-9508-50050d8ab2d5</a:t>
             </a:r>
           </a:p>
         </p:txBody>
@@ -10750,7 +10750,7 @@
                 </a:solidFill>
                 <a:latin typeface="Yu Gothic"/>
               </a:rPr>
-              <a:t>08 / 08   NotebookLM CLI outline / notebook fd58e18d-1c62-43c7-9425-0e708879ec25</a:t>
+              <a:t>08 / 08   NotebookLM CLI outline / notebook 75521ea6-6b9b-47b2-9508-50050d8ab2d5</a:t>
             </a:r>
           </a:p>
         </p:txBody>

</xml_diff>

<commit_message>
chore(T826): harden NotebookLM sync closeout
</commit_message>
<xml_diff>
--- a/exports/knowledge_flow/mighty_skill_bridge_ceo_presentation_2026-06-02.pptx
+++ b/exports/knowledge_flow/mighty_skill_bridge_ceo_presentation_2026-06-02.pptx
@@ -3240,7 +3240,7 @@
                 </a:solidFill>
                 <a:latin typeface="Yu Gothic"/>
               </a:rPr>
-              <a:t>01 / 08   NotebookLM CLI outline / notebook 75521ea6-6b9b-47b2-9508-50050d8ab2d5</a:t>
+              <a:t>01 / 08   NotebookLM CLI outline / notebook 4934c12b-b270-4739-97a1-b04b5b84eaaf</a:t>
             </a:r>
           </a:p>
         </p:txBody>
@@ -4134,7 +4134,7 @@
                 </a:solidFill>
                 <a:latin typeface="Yu Gothic"/>
               </a:rPr>
-              <a:t>02 / 08   NotebookLM CLI outline / notebook 75521ea6-6b9b-47b2-9508-50050d8ab2d5</a:t>
+              <a:t>02 / 08   NotebookLM CLI outline / notebook 4934c12b-b270-4739-97a1-b04b5b84eaaf</a:t>
             </a:r>
           </a:p>
         </p:txBody>
@@ -4584,7 +4584,7 @@
                 </a:solidFill>
                 <a:latin typeface="Yu Gothic"/>
               </a:rPr>
-              <a:t>244 tasks</a:t>
+              <a:t>245 tasks</a:t>
             </a:r>
           </a:p>
         </p:txBody>
@@ -5044,7 +5044,7 @@
                 </a:solidFill>
                 <a:latin typeface="Yu Gothic"/>
               </a:rPr>
-              <a:t>03 / 08   NotebookLM CLI outline / notebook 75521ea6-6b9b-47b2-9508-50050d8ab2d5</a:t>
+              <a:t>03 / 08   NotebookLM CLI outline / notebook 4934c12b-b270-4739-97a1-b04b5b84eaaf</a:t>
             </a:r>
           </a:p>
         </p:txBody>
@@ -6000,7 +6000,7 @@
               </a:defRPr>
             </a:pPr>
             <a:r>
-              <a:t>NotebookLM sources ready: 91</a:t>
+              <a:t>NotebookLM sources ready: 92</a:t>
             </a:r>
           </a:p>
           <a:p>
@@ -6184,7 +6184,7 @@
                 </a:solidFill>
                 <a:latin typeface="Yu Gothic"/>
               </a:rPr>
-              <a:t>04 / 08   NotebookLM CLI outline / notebook 75521ea6-6b9b-47b2-9508-50050d8ab2d5</a:t>
+              <a:t>04 / 08   NotebookLM CLI outline / notebook 4934c12b-b270-4739-97a1-b04b5b84eaaf</a:t>
             </a:r>
           </a:p>
         </p:txBody>
@@ -7393,7 +7393,7 @@
                 </a:solidFill>
                 <a:latin typeface="Yu Gothic"/>
               </a:rPr>
-              <a:t>05 / 08   NotebookLM CLI outline / notebook 75521ea6-6b9b-47b2-9508-50050d8ab2d5</a:t>
+              <a:t>05 / 08   NotebookLM CLI outline / notebook 4934c12b-b270-4739-97a1-b04b5b84eaaf</a:t>
             </a:r>
           </a:p>
         </p:txBody>
@@ -8183,7 +8183,7 @@
               </a:defRPr>
             </a:pPr>
             <a:r>
-              <a:t>NotebookLM notebook: 75521ea6-6b9b-47b2-9508-50050d8ab2d5</a:t>
+              <a:t>NotebookLM notebook: 4934c12b-b270-4739-97a1-b04b5b84eaaf</a:t>
             </a:r>
           </a:p>
           <a:p>
@@ -8383,7 +8383,7 @@
                 </a:solidFill>
                 <a:latin typeface="Yu Gothic"/>
               </a:rPr>
-              <a:t>06 / 08   NotebookLM CLI outline / notebook 75521ea6-6b9b-47b2-9508-50050d8ab2d5</a:t>
+              <a:t>06 / 08   NotebookLM CLI outline / notebook 4934c12b-b270-4739-97a1-b04b5b84eaaf</a:t>
             </a:r>
           </a:p>
         </p:txBody>
@@ -9646,7 +9646,7 @@
                 </a:solidFill>
                 <a:latin typeface="Yu Gothic"/>
               </a:rPr>
-              <a:t>07 / 08   NotebookLM CLI outline / notebook 75521ea6-6b9b-47b2-9508-50050d8ab2d5</a:t>
+              <a:t>07 / 08   NotebookLM CLI outline / notebook 4934c12b-b270-4739-97a1-b04b5b84eaaf</a:t>
             </a:r>
           </a:p>
         </p:txBody>
@@ -10750,7 +10750,7 @@
                 </a:solidFill>
                 <a:latin typeface="Yu Gothic"/>
               </a:rPr>
-              <a:t>08 / 08   NotebookLM CLI outline / notebook 75521ea6-6b9b-47b2-9508-50050d8ab2d5</a:t>
+              <a:t>08 / 08   NotebookLM CLI outline / notebook 4934c12b-b270-4739-97a1-b04b5b84eaaf</a:t>
             </a:r>
           </a:p>
         </p:txBody>

</xml_diff>

<commit_message>
[codex] ops: add supabase pg14 eol gate
</commit_message>
<xml_diff>
--- a/exports/knowledge_flow/mighty_skill_bridge_ceo_presentation_2026-06-02.pptx
+++ b/exports/knowledge_flow/mighty_skill_bridge_ceo_presentation_2026-06-02.pptx
@@ -4584,7 +4584,7 @@
                 </a:solidFill>
                 <a:latin typeface="Yu Gothic"/>
               </a:rPr>
-              <a:t>246 tasks</a:t>
+              <a:t>247 tasks</a:t>
             </a:r>
           </a:p>
         </p:txBody>
@@ -6000,7 +6000,7 @@
               </a:defRPr>
             </a:pPr>
             <a:r>
-              <a:t>NotebookLM sources ready: 92</a:t>
+              <a:t>NotebookLM sources ready: 93</a:t>
             </a:r>
           </a:p>
           <a:p>

</xml_diff>

<commit_message>
Complete external pentest review
</commit_message>
<xml_diff>
--- a/exports/knowledge_flow/mighty_skill_bridge_ceo_presentation_2026-06-02.pptx
+++ b/exports/knowledge_flow/mighty_skill_bridge_ceo_presentation_2026-06-02.pptx
@@ -4584,7 +4584,7 @@
                 </a:solidFill>
                 <a:latin typeface="Yu Gothic"/>
               </a:rPr>
-              <a:t>249 tasks</a:t>
+              <a:t>256 tasks</a:t>
             </a:r>
           </a:p>
         </p:txBody>
@@ -6000,7 +6000,7 @@
               </a:defRPr>
             </a:pPr>
             <a:r>
-              <a:t>NotebookLM sources ready: 95</a:t>
+              <a:t>NotebookLM sources ready: 96</a:t>
             </a:r>
           </a:p>
           <a:p>

</xml_diff>

<commit_message>
Complete employee assessment tool research
</commit_message>
<xml_diff>
--- a/exports/knowledge_flow/mighty_skill_bridge_ceo_presentation_2026-06-02.pptx
+++ b/exports/knowledge_flow/mighty_skill_bridge_ceo_presentation_2026-06-02.pptx
@@ -4584,7 +4584,7 @@
                 </a:solidFill>
                 <a:latin typeface="Yu Gothic"/>
               </a:rPr>
-              <a:t>256 tasks</a:t>
+              <a:t>257 tasks</a:t>
             </a:r>
           </a:p>
         </p:txBody>
@@ -6000,7 +6000,7 @@
               </a:defRPr>
             </a:pPr>
             <a:r>
-              <a:t>NotebookLM sources ready: 96</a:t>
+              <a:t>NotebookLM sources ready: 97</a:t>
             </a:r>
           </a:p>
           <a:p>

</xml_diff>

<commit_message>
Complete assessment PoC plan and internal nav sync
</commit_message>
<xml_diff>
--- a/exports/knowledge_flow/mighty_skill_bridge_ceo_presentation_2026-06-02.pptx
+++ b/exports/knowledge_flow/mighty_skill_bridge_ceo_presentation_2026-06-02.pptx
@@ -4584,7 +4584,7 @@
                 </a:solidFill>
                 <a:latin typeface="Yu Gothic"/>
               </a:rPr>
-              <a:t>257 tasks</a:t>
+              <a:t>262 tasks</a:t>
             </a:r>
           </a:p>
         </p:txBody>
@@ -6000,7 +6000,7 @@
               </a:defRPr>
             </a:pPr>
             <a:r>
-              <a:t>NotebookLM sources ready: 98</a:t>
+              <a:t>NotebookLM sources ready: 99</a:t>
             </a:r>
           </a:p>
           <a:p>

</xml_diff>

<commit_message>
Add WBS completion coverage gates
</commit_message>
<xml_diff>
--- a/exports/knowledge_flow/mighty_skill_bridge_ceo_presentation_2026-06-02.pptx
+++ b/exports/knowledge_flow/mighty_skill_bridge_ceo_presentation_2026-06-02.pptx
@@ -3240,7 +3240,7 @@
                 </a:solidFill>
                 <a:latin typeface="Yu Gothic"/>
               </a:rPr>
-              <a:t>01 / 08   NotebookLM CLI outline / notebook 4934c12b-b270-4739-97a1-b04b5b84eaaf</a:t>
+              <a:t>01 / 08   NotebookLM CLI outline / notebook 75521ea6-6b9b-47b2-9508-50050d8ab2d5</a:t>
             </a:r>
           </a:p>
         </p:txBody>
@@ -4134,7 +4134,7 @@
                 </a:solidFill>
                 <a:latin typeface="Yu Gothic"/>
               </a:rPr>
-              <a:t>02 / 08   NotebookLM CLI outline / notebook 4934c12b-b270-4739-97a1-b04b5b84eaaf</a:t>
+              <a:t>02 / 08   NotebookLM CLI outline / notebook 75521ea6-6b9b-47b2-9508-50050d8ab2d5</a:t>
             </a:r>
           </a:p>
         </p:txBody>
@@ -4584,7 +4584,7 @@
                 </a:solidFill>
                 <a:latin typeface="Yu Gothic"/>
               </a:rPr>
-              <a:t>262 tasks</a:t>
+              <a:t>269 tasks</a:t>
             </a:r>
           </a:p>
         </p:txBody>
@@ -5044,7 +5044,7 @@
                 </a:solidFill>
                 <a:latin typeface="Yu Gothic"/>
               </a:rPr>
-              <a:t>03 / 08   NotebookLM CLI outline / notebook 4934c12b-b270-4739-97a1-b04b5b84eaaf</a:t>
+              <a:t>03 / 08   NotebookLM CLI outline / notebook 75521ea6-6b9b-47b2-9508-50050d8ab2d5</a:t>
             </a:r>
           </a:p>
         </p:txBody>
@@ -6000,7 +6000,7 @@
               </a:defRPr>
             </a:pPr>
             <a:r>
-              <a:t>NotebookLM sources ready: 101</a:t>
+              <a:t>NotebookLM sources ready: 102</a:t>
             </a:r>
           </a:p>
           <a:p>
@@ -6184,7 +6184,7 @@
                 </a:solidFill>
                 <a:latin typeface="Yu Gothic"/>
               </a:rPr>
-              <a:t>04 / 08   NotebookLM CLI outline / notebook 4934c12b-b270-4739-97a1-b04b5b84eaaf</a:t>
+              <a:t>04 / 08   NotebookLM CLI outline / notebook 75521ea6-6b9b-47b2-9508-50050d8ab2d5</a:t>
             </a:r>
           </a:p>
         </p:txBody>
@@ -7393,7 +7393,7 @@
                 </a:solidFill>
                 <a:latin typeface="Yu Gothic"/>
               </a:rPr>
-              <a:t>05 / 08   NotebookLM CLI outline / notebook 4934c12b-b270-4739-97a1-b04b5b84eaaf</a:t>
+              <a:t>05 / 08   NotebookLM CLI outline / notebook 75521ea6-6b9b-47b2-9508-50050d8ab2d5</a:t>
             </a:r>
           </a:p>
         </p:txBody>
@@ -8183,7 +8183,7 @@
               </a:defRPr>
             </a:pPr>
             <a:r>
-              <a:t>NotebookLM notebook: 4934c12b-b270-4739-97a1-b04b5b84eaaf</a:t>
+              <a:t>NotebookLM notebook: 75521ea6-6b9b-47b2-9508-50050d8ab2d5</a:t>
             </a:r>
           </a:p>
           <a:p>
@@ -8383,7 +8383,7 @@
                 </a:solidFill>
                 <a:latin typeface="Yu Gothic"/>
               </a:rPr>
-              <a:t>06 / 08   NotebookLM CLI outline / notebook 4934c12b-b270-4739-97a1-b04b5b84eaaf</a:t>
+              <a:t>06 / 08   NotebookLM CLI outline / notebook 75521ea6-6b9b-47b2-9508-50050d8ab2d5</a:t>
             </a:r>
           </a:p>
         </p:txBody>
@@ -9646,7 +9646,7 @@
                 </a:solidFill>
                 <a:latin typeface="Yu Gothic"/>
               </a:rPr>
-              <a:t>07 / 08   NotebookLM CLI outline / notebook 4934c12b-b270-4739-97a1-b04b5b84eaaf</a:t>
+              <a:t>07 / 08   NotebookLM CLI outline / notebook 75521ea6-6b9b-47b2-9508-50050d8ab2d5</a:t>
             </a:r>
           </a:p>
         </p:txBody>
@@ -10750,7 +10750,7 @@
                 </a:solidFill>
                 <a:latin typeface="Yu Gothic"/>
               </a:rPr>
-              <a:t>08 / 08   NotebookLM CLI outline / notebook 4934c12b-b270-4739-97a1-b04b5b84eaaf</a:t>
+              <a:t>08 / 08   NotebookLM CLI outline / notebook 75521ea6-6b9b-47b2-9508-50050d8ab2d5</a:t>
             </a:r>
           </a:p>
         </p:txBody>

</xml_diff>

<commit_message>
Record WBS completion gate recheck
</commit_message>
<xml_diff>
--- a/exports/knowledge_flow/mighty_skill_bridge_ceo_presentation_2026-06-02.pptx
+++ b/exports/knowledge_flow/mighty_skill_bridge_ceo_presentation_2026-06-02.pptx
@@ -3240,7 +3240,7 @@
                 </a:solidFill>
                 <a:latin typeface="Yu Gothic"/>
               </a:rPr>
-              <a:t>01 / 08   NotebookLM CLI outline / notebook 75521ea6-6b9b-47b2-9508-50050d8ab2d5</a:t>
+              <a:t>01 / 08   NotebookLM CLI outline / notebook 4934c12b-b270-4739-97a1-b04b5b84eaaf</a:t>
             </a:r>
           </a:p>
         </p:txBody>
@@ -4134,7 +4134,7 @@
                 </a:solidFill>
                 <a:latin typeface="Yu Gothic"/>
               </a:rPr>
-              <a:t>02 / 08   NotebookLM CLI outline / notebook 75521ea6-6b9b-47b2-9508-50050d8ab2d5</a:t>
+              <a:t>02 / 08   NotebookLM CLI outline / notebook 4934c12b-b270-4739-97a1-b04b5b84eaaf</a:t>
             </a:r>
           </a:p>
         </p:txBody>
@@ -4584,7 +4584,7 @@
                 </a:solidFill>
                 <a:latin typeface="Yu Gothic"/>
               </a:rPr>
-              <a:t>269 tasks</a:t>
+              <a:t>270 tasks</a:t>
             </a:r>
           </a:p>
         </p:txBody>
@@ -5044,7 +5044,7 @@
                 </a:solidFill>
                 <a:latin typeface="Yu Gothic"/>
               </a:rPr>
-              <a:t>03 / 08   NotebookLM CLI outline / notebook 75521ea6-6b9b-47b2-9508-50050d8ab2d5</a:t>
+              <a:t>03 / 08   NotebookLM CLI outline / notebook 4934c12b-b270-4739-97a1-b04b5b84eaaf</a:t>
             </a:r>
           </a:p>
         </p:txBody>
@@ -6000,7 +6000,7 @@
               </a:defRPr>
             </a:pPr>
             <a:r>
-              <a:t>NotebookLM sources ready: 102</a:t>
+              <a:t>NotebookLM sources ready: 103</a:t>
             </a:r>
           </a:p>
           <a:p>
@@ -6184,7 +6184,7 @@
                 </a:solidFill>
                 <a:latin typeface="Yu Gothic"/>
               </a:rPr>
-              <a:t>04 / 08   NotebookLM CLI outline / notebook 75521ea6-6b9b-47b2-9508-50050d8ab2d5</a:t>
+              <a:t>04 / 08   NotebookLM CLI outline / notebook 4934c12b-b270-4739-97a1-b04b5b84eaaf</a:t>
             </a:r>
           </a:p>
         </p:txBody>
@@ -7393,7 +7393,7 @@
                 </a:solidFill>
                 <a:latin typeface="Yu Gothic"/>
               </a:rPr>
-              <a:t>05 / 08   NotebookLM CLI outline / notebook 75521ea6-6b9b-47b2-9508-50050d8ab2d5</a:t>
+              <a:t>05 / 08   NotebookLM CLI outline / notebook 4934c12b-b270-4739-97a1-b04b5b84eaaf</a:t>
             </a:r>
           </a:p>
         </p:txBody>
@@ -8183,7 +8183,7 @@
               </a:defRPr>
             </a:pPr>
             <a:r>
-              <a:t>NotebookLM notebook: 75521ea6-6b9b-47b2-9508-50050d8ab2d5</a:t>
+              <a:t>NotebookLM notebook: 4934c12b-b270-4739-97a1-b04b5b84eaaf</a:t>
             </a:r>
           </a:p>
           <a:p>
@@ -8383,7 +8383,7 @@
                 </a:solidFill>
                 <a:latin typeface="Yu Gothic"/>
               </a:rPr>
-              <a:t>06 / 08   NotebookLM CLI outline / notebook 75521ea6-6b9b-47b2-9508-50050d8ab2d5</a:t>
+              <a:t>06 / 08   NotebookLM CLI outline / notebook 4934c12b-b270-4739-97a1-b04b5b84eaaf</a:t>
             </a:r>
           </a:p>
         </p:txBody>
@@ -9646,7 +9646,7 @@
                 </a:solidFill>
                 <a:latin typeface="Yu Gothic"/>
               </a:rPr>
-              <a:t>07 / 08   NotebookLM CLI outline / notebook 75521ea6-6b9b-47b2-9508-50050d8ab2d5</a:t>
+              <a:t>07 / 08   NotebookLM CLI outline / notebook 4934c12b-b270-4739-97a1-b04b5b84eaaf</a:t>
             </a:r>
           </a:p>
         </p:txBody>
@@ -10750,7 +10750,7 @@
                 </a:solidFill>
                 <a:latin typeface="Yu Gothic"/>
               </a:rPr>
-              <a:t>08 / 08   NotebookLM CLI outline / notebook 75521ea6-6b9b-47b2-9508-50050d8ab2d5</a:t>
+              <a:t>08 / 08   NotebookLM CLI outline / notebook 4934c12b-b270-4739-97a1-b04b5b84eaaf</a:t>
             </a:r>
           </a:p>
         </p:txBody>

</xml_diff>

<commit_message>
Add issue and QA completion gate to WBS
</commit_message>
<xml_diff>
--- a/exports/knowledge_flow/mighty_skill_bridge_ceo_presentation_2026-06-02.pptx
+++ b/exports/knowledge_flow/mighty_skill_bridge_ceo_presentation_2026-06-02.pptx
@@ -4584,7 +4584,7 @@
                 </a:solidFill>
                 <a:latin typeface="Yu Gothic"/>
               </a:rPr>
-              <a:t>271 tasks</a:t>
+              <a:t>273 tasks</a:t>
             </a:r>
           </a:p>
         </p:txBody>
@@ -6000,7 +6000,7 @@
               </a:defRPr>
             </a:pPr>
             <a:r>
-              <a:t>NotebookLM sources ready: 103</a:t>
+              <a:t>NotebookLM sources ready: 104</a:t>
             </a:r>
           </a:p>
           <a:p>

</xml_diff>

<commit_message>
Add T855 custom domain uptime recovery gate
</commit_message>
<xml_diff>
--- a/exports/knowledge_flow/mighty_skill_bridge_ceo_presentation_2026-06-02.pptx
+++ b/exports/knowledge_flow/mighty_skill_bridge_ceo_presentation_2026-06-02.pptx
@@ -4584,7 +4584,7 @@
                 </a:solidFill>
                 <a:latin typeface="Yu Gothic"/>
               </a:rPr>
-              <a:t>273 tasks</a:t>
+              <a:t>274 tasks</a:t>
             </a:r>
           </a:p>
         </p:txBody>
@@ -6000,7 +6000,7 @@
               </a:defRPr>
             </a:pPr>
             <a:r>
-              <a:t>NotebookLM sources ready: 108</a:t>
+              <a:t>NotebookLM sources ready: 109</a:t>
             </a:r>
           </a:p>
           <a:p>

</xml_diff>

<commit_message>
Complete T856 custom domain DNS diagnostics
</commit_message>
<xml_diff>
--- a/exports/knowledge_flow/mighty_skill_bridge_ceo_presentation_2026-06-02.pptx
+++ b/exports/knowledge_flow/mighty_skill_bridge_ceo_presentation_2026-06-02.pptx
@@ -4584,7 +4584,7 @@
                 </a:solidFill>
                 <a:latin typeface="Yu Gothic"/>
               </a:rPr>
-              <a:t>274 tasks</a:t>
+              <a:t>275 tasks</a:t>
             </a:r>
           </a:p>
         </p:txBody>
@@ -6000,7 +6000,7 @@
               </a:defRPr>
             </a:pPr>
             <a:r>
-              <a:t>NotebookLM sources ready: 109</a:t>
+              <a:t>NotebookLM sources ready: 110</a:t>
             </a:r>
           </a:p>
           <a:p>

</xml_diff>

<commit_message>
Complete T857 WBS OAuth sync audit
</commit_message>
<xml_diff>
--- a/exports/knowledge_flow/mighty_skill_bridge_ceo_presentation_2026-06-02.pptx
+++ b/exports/knowledge_flow/mighty_skill_bridge_ceo_presentation_2026-06-02.pptx
@@ -4584,7 +4584,7 @@
                 </a:solidFill>
                 <a:latin typeface="Yu Gothic"/>
               </a:rPr>
-              <a:t>275 tasks</a:t>
+              <a:t>276 tasks</a:t>
             </a:r>
           </a:p>
         </p:txBody>
@@ -6000,7 +6000,7 @@
               </a:defRPr>
             </a:pPr>
             <a:r>
-              <a:t>NotebookLM sources ready: 111</a:t>
+              <a:t>NotebookLM sources ready: 115</a:t>
             </a:r>
           </a:p>
           <a:p>

</xml_diff>

<commit_message>
Complete T770 load test audit
</commit_message>
<xml_diff>
--- a/exports/knowledge_flow/mighty_skill_bridge_ceo_presentation_2026-06-02.pptx
+++ b/exports/knowledge_flow/mighty_skill_bridge_ceo_presentation_2026-06-02.pptx
@@ -4584,7 +4584,7 @@
                 </a:solidFill>
                 <a:latin typeface="Yu Gothic"/>
               </a:rPr>
-              <a:t>276 tasks</a:t>
+              <a:t>277 tasks</a:t>
             </a:r>
           </a:p>
         </p:txBody>
@@ -6000,7 +6000,7 @@
               </a:defRPr>
             </a:pPr>
             <a:r>
-              <a:t>NotebookLM sources ready: 115</a:t>
+              <a:t>NotebookLM sources ready: 116</a:t>
             </a:r>
           </a:p>
           <a:p>

</xml_diff>

<commit_message>
Sync closeout artifacts for T859 re-baseline
Regenerated NotebookLM/CEO deck manifests and development plan ICS after Sheets/Calendar/Drive sync.

Co-Authored-By: Claude Fable 5 <noreply@anthropic.com>
</commit_message>
<xml_diff>
--- a/exports/knowledge_flow/mighty_skill_bridge_ceo_presentation_2026-06-02.pptx
+++ b/exports/knowledge_flow/mighty_skill_bridge_ceo_presentation_2026-06-02.pptx
@@ -4584,7 +4584,7 @@
                 </a:solidFill>
                 <a:latin typeface="Yu Gothic"/>
               </a:rPr>
-              <a:t>277 tasks</a:t>
+              <a:t>278 tasks</a:t>
             </a:r>
           </a:p>
         </p:txBody>
@@ -6000,7 +6000,7 @@
               </a:defRPr>
             </a:pPr>
             <a:r>
-              <a:t>NotebookLM sources ready: 116</a:t>
+              <a:t>NotebookLM sources ready: 117</a:t>
             </a:r>
           </a:p>
           <a:p>

</xml_diff>

<commit_message>
Sync calendar ICS and NotebookLM artifacts for T833 closeout
Co-Authored-By: Claude Fable 5 <noreply@anthropic.com>
</commit_message>
<xml_diff>
--- a/exports/knowledge_flow/mighty_skill_bridge_ceo_presentation_2026-06-02.pptx
+++ b/exports/knowledge_flow/mighty_skill_bridge_ceo_presentation_2026-06-02.pptx
@@ -4584,7 +4584,7 @@
                 </a:solidFill>
                 <a:latin typeface="Yu Gothic"/>
               </a:rPr>
-              <a:t>278 tasks</a:t>
+              <a:t>294 tasks</a:t>
             </a:r>
           </a:p>
         </p:txBody>
@@ -6000,7 +6000,7 @@
               </a:defRPr>
             </a:pPr>
             <a:r>
-              <a:t>NotebookLM sources ready: 117</a:t>
+              <a:t>NotebookLM sources ready: 126</a:t>
             </a:r>
           </a:p>
           <a:p>

</xml_diff>

<commit_message>
chore(T893): add targeted WBS GitHub sync
</commit_message>
<xml_diff>
--- a/exports/knowledge_flow/mighty_skill_bridge_ceo_presentation_2026-06-02.pptx
+++ b/exports/knowledge_flow/mighty_skill_bridge_ceo_presentation_2026-06-02.pptx
@@ -3240,7 +3240,7 @@
                 </a:solidFill>
                 <a:latin typeface="Yu Gothic"/>
               </a:rPr>
-              <a:t>01 / 08   NotebookLM CLI outline / notebook 4934c12b-b270-4739-97a1-b04b5b84eaaf</a:t>
+              <a:t>01 / 08   NotebookLM CLI outline / notebook 75521ea6-6b9b-47b2-9508-50050d8ab2d5</a:t>
             </a:r>
           </a:p>
         </p:txBody>
@@ -4134,7 +4134,7 @@
                 </a:solidFill>
                 <a:latin typeface="Yu Gothic"/>
               </a:rPr>
-              <a:t>02 / 08   NotebookLM CLI outline / notebook 4934c12b-b270-4739-97a1-b04b5b84eaaf</a:t>
+              <a:t>02 / 08   NotebookLM CLI outline / notebook 75521ea6-6b9b-47b2-9508-50050d8ab2d5</a:t>
             </a:r>
           </a:p>
         </p:txBody>
@@ -4584,7 +4584,7 @@
                 </a:solidFill>
                 <a:latin typeface="Yu Gothic"/>
               </a:rPr>
-              <a:t>298 tasks</a:t>
+              <a:t>320 tasks</a:t>
             </a:r>
           </a:p>
         </p:txBody>
@@ -5044,7 +5044,7 @@
                 </a:solidFill>
                 <a:latin typeface="Yu Gothic"/>
               </a:rPr>
-              <a:t>03 / 08   NotebookLM CLI outline / notebook 4934c12b-b270-4739-97a1-b04b5b84eaaf</a:t>
+              <a:t>03 / 08   NotebookLM CLI outline / notebook 75521ea6-6b9b-47b2-9508-50050d8ab2d5</a:t>
             </a:r>
           </a:p>
         </p:txBody>
@@ -6000,7 +6000,7 @@
               </a:defRPr>
             </a:pPr>
             <a:r>
-              <a:t>NotebookLM sources ready: 126</a:t>
+              <a:t>NotebookLM sources ready: 135</a:t>
             </a:r>
           </a:p>
           <a:p>
@@ -6184,7 +6184,7 @@
                 </a:solidFill>
                 <a:latin typeface="Yu Gothic"/>
               </a:rPr>
-              <a:t>04 / 08   NotebookLM CLI outline / notebook 4934c12b-b270-4739-97a1-b04b5b84eaaf</a:t>
+              <a:t>04 / 08   NotebookLM CLI outline / notebook 75521ea6-6b9b-47b2-9508-50050d8ab2d5</a:t>
             </a:r>
           </a:p>
         </p:txBody>
@@ -7393,7 +7393,7 @@
                 </a:solidFill>
                 <a:latin typeface="Yu Gothic"/>
               </a:rPr>
-              <a:t>05 / 08   NotebookLM CLI outline / notebook 4934c12b-b270-4739-97a1-b04b5b84eaaf</a:t>
+              <a:t>05 / 08   NotebookLM CLI outline / notebook 75521ea6-6b9b-47b2-9508-50050d8ab2d5</a:t>
             </a:r>
           </a:p>
         </p:txBody>
@@ -8183,7 +8183,7 @@
               </a:defRPr>
             </a:pPr>
             <a:r>
-              <a:t>NotebookLM notebook: 4934c12b-b270-4739-97a1-b04b5b84eaaf</a:t>
+              <a:t>NotebookLM notebook: 75521ea6-6b9b-47b2-9508-50050d8ab2d5</a:t>
             </a:r>
           </a:p>
           <a:p>
@@ -8383,7 +8383,7 @@
                 </a:solidFill>
                 <a:latin typeface="Yu Gothic"/>
               </a:rPr>
-              <a:t>06 / 08   NotebookLM CLI outline / notebook 4934c12b-b270-4739-97a1-b04b5b84eaaf</a:t>
+              <a:t>06 / 08   NotebookLM CLI outline / notebook 75521ea6-6b9b-47b2-9508-50050d8ab2d5</a:t>
             </a:r>
           </a:p>
         </p:txBody>
@@ -9646,7 +9646,7 @@
                 </a:solidFill>
                 <a:latin typeface="Yu Gothic"/>
               </a:rPr>
-              <a:t>07 / 08   NotebookLM CLI outline / notebook 4934c12b-b270-4739-97a1-b04b5b84eaaf</a:t>
+              <a:t>07 / 08   NotebookLM CLI outline / notebook 75521ea6-6b9b-47b2-9508-50050d8ab2d5</a:t>
             </a:r>
           </a:p>
         </p:txBody>
@@ -10750,7 +10750,7 @@
                 </a:solidFill>
                 <a:latin typeface="Yu Gothic"/>
               </a:rPr>
-              <a:t>08 / 08   NotebookLM CLI outline / notebook 4934c12b-b270-4739-97a1-b04b5b84eaaf</a:t>
+              <a:t>08 / 08   NotebookLM CLI outline / notebook 75521ea6-6b9b-47b2-9508-50050d8ab2d5</a:t>
             </a:r>
           </a:p>
         </p:txBody>

</xml_diff>

<commit_message>
chore(T893): sync WBS tasks to GitHub Project
</commit_message>
<xml_diff>
--- a/exports/knowledge_flow/mighty_skill_bridge_ceo_presentation_2026-06-02.pptx
+++ b/exports/knowledge_flow/mighty_skill_bridge_ceo_presentation_2026-06-02.pptx
@@ -10096,7 +10096,7 @@
                 </a:solidFill>
                 <a:latin typeface="Yu Gothic"/>
               </a:rPr>
-              <a:t>CLI未検出、送信MCP未露出。</a:t>
+              <a:t>投稿先と共有範囲の承認が必要。</a:t>
             </a:r>
           </a:p>
         </p:txBody>
@@ -10131,7 +10131,7 @@
                 </a:solidFill>
                 <a:latin typeface="Yu Gothic"/>
               </a:rPr>
-              <a:t>投稿先と共有範囲をIssue #2で管理</a:t>
+              <a:t>承認後に公式コネクタで送信</a:t>
             </a:r>
           </a:p>
         </p:txBody>
@@ -10246,7 +10246,7 @@
                 </a:solidFill>
                 <a:latin typeface="Yu Gothic"/>
               </a:rPr>
-              <a:t>read:project / project scope不足。</a:t>
+              <a:t>Project #1へWBS対象限定同期済み。</a:t>
             </a:r>
           </a:p>
         </p:txBody>
@@ -10281,7 +10281,7 @@
                 </a:solidFill>
                 <a:latin typeface="Yu Gothic"/>
               </a:rPr>
-              <a:t>Issue #8でOAuth復旧後に配置</a:t>
+              <a:t>完了・更新タスクだけを継続同期</a:t>
             </a:r>
           </a:p>
         </p:txBody>
@@ -10550,7 +10550,7 @@
               </a:defRPr>
             </a:pPr>
             <a:r>
-              <a:t>GitHub Project check: gh project list -&gt; missing read:project</a:t>
+              <a:t>GitHub Project: Project #1 operational</a:t>
             </a:r>
           </a:p>
           <a:p>
@@ -10566,7 +10566,7 @@
               </a:defRPr>
             </a:pPr>
             <a:r>
-              <a:t>Slack check: local slack CLI not found; connector send tool not exposed</a:t>
+              <a:t>WBS sync: scripts/sync_wbs_to_github.py</a:t>
             </a:r>
           </a:p>
           <a:p>
@@ -10582,7 +10582,7 @@
               </a:defRPr>
             </a:pPr>
             <a:r>
-              <a:t>Issue #8 / #2で残課題化</a:t>
+              <a:t>Slack: destination approval required before posting</a:t>
             </a:r>
           </a:p>
         </p:txBody>
@@ -12122,7 +12122,7 @@
               </a:defRPr>
             </a:pPr>
             <a:r>
-              <a:t>Issue tracking: GitHub Issues #1-#11/#13/#14/#16</a:t>
+              <a:t>Issue/Project sync: scripts/sync_wbs_to_github.py</a:t>
             </a:r>
           </a:p>
         </p:txBody>

</xml_diff>

<commit_message>
Add shared lane preflight guard (T894)
</commit_message>
<xml_diff>
--- a/exports/knowledge_flow/mighty_skill_bridge_ceo_presentation_2026-06-02.pptx
+++ b/exports/knowledge_flow/mighty_skill_bridge_ceo_presentation_2026-06-02.pptx
@@ -4584,7 +4584,7 @@
                 </a:solidFill>
                 <a:latin typeface="Yu Gothic"/>
               </a:rPr>
-              <a:t>320 tasks</a:t>
+              <a:t>321 tasks</a:t>
             </a:r>
           </a:p>
         </p:txBody>
@@ -6000,7 +6000,7 @@
               </a:defRPr>
             </a:pPr>
             <a:r>
-              <a:t>NotebookLM sources ready: 135</a:t>
+              <a:t>NotebookLM sources ready: 136</a:t>
             </a:r>
           </a:p>
           <a:p>

</xml_diff>

<commit_message>
chore: refresh T879 closeout artifacts
Audit trails, knowledge-flow pack, NotebookLM manifests, CEO deck,
development plan ICS, and the T879/T898 GitHub sync report regenerated
by the closeout pipeline.

Co-Authored-By: Claude Fable 5 <noreply@anthropic.com>
</commit_message>
<xml_diff>
--- a/exports/knowledge_flow/mighty_skill_bridge_ceo_presentation_2026-06-02.pptx
+++ b/exports/knowledge_flow/mighty_skill_bridge_ceo_presentation_2026-06-02.pptx
@@ -4584,7 +4584,7 @@
                 </a:solidFill>
                 <a:latin typeface="Yu Gothic"/>
               </a:rPr>
-              <a:t>321 tasks</a:t>
+              <a:t>325 tasks</a:t>
             </a:r>
           </a:p>
         </p:txBody>
@@ -6000,7 +6000,7 @@
               </a:defRPr>
             </a:pPr>
             <a:r>
-              <a:t>NotebookLM sources ready: 136</a:t>
+              <a:t>NotebookLM sources ready: 137</a:t>
             </a:r>
           </a:p>
           <a:p>

</xml_diff>

<commit_message>
chore: refresh T801 closeout artifacts
Audit trails, knowledge-flow pack, NotebookLM manifests, CEO deck,
development plan ICS, and the T801/T899 GitHub sync report regenerated
by the closeout pipeline.

Co-Authored-By: Claude Fable 5 <noreply@anthropic.com>
</commit_message>
<xml_diff>
--- a/exports/knowledge_flow/mighty_skill_bridge_ceo_presentation_2026-06-02.pptx
+++ b/exports/knowledge_flow/mighty_skill_bridge_ceo_presentation_2026-06-02.pptx
@@ -4584,7 +4584,7 @@
                 </a:solidFill>
                 <a:latin typeface="Yu Gothic"/>
               </a:rPr>
-              <a:t>325 tasks</a:t>
+              <a:t>326 tasks</a:t>
             </a:r>
           </a:p>
         </p:txBody>
@@ -6000,7 +6000,7 @@
               </a:defRPr>
             </a:pPr>
             <a:r>
-              <a:t>NotebookLM sources ready: 137</a:t>
+              <a:t>NotebookLM sources ready: 138</a:t>
             </a:r>
           </a:p>
           <a:p>

</xml_diff>

<commit_message>
chore: refresh T839_1 closeout artifacts
Audit trails, knowledge-flow pack, NotebookLM manifests, CEO deck, and the
T839_1 GitHub sync report regenerated by the closeout pipeline.

Co-Authored-By: Claude Fable 5 <noreply@anthropic.com>
</commit_message>
<xml_diff>
--- a/exports/knowledge_flow/mighty_skill_bridge_ceo_presentation_2026-06-02.pptx
+++ b/exports/knowledge_flow/mighty_skill_bridge_ceo_presentation_2026-06-02.pptx
@@ -4584,7 +4584,7 @@
                 </a:solidFill>
                 <a:latin typeface="Yu Gothic"/>
               </a:rPr>
-              <a:t>326 tasks</a:t>
+              <a:t>327 tasks</a:t>
             </a:r>
           </a:p>
         </p:txBody>
@@ -6000,7 +6000,7 @@
               </a:defRPr>
             </a:pPr>
             <a:r>
-              <a:t>NotebookLM sources ready: 138</a:t>
+              <a:t>NotebookLM sources ready: 139</a:t>
             </a:r>
           </a:p>
           <a:p>

</xml_diff>

<commit_message>
fix(auth): restore locked UI after valid session
</commit_message>
<xml_diff>
--- a/exports/knowledge_flow/mighty_skill_bridge_ceo_presentation_2026-06-02.pptx
+++ b/exports/knowledge_flow/mighty_skill_bridge_ceo_presentation_2026-06-02.pptx
@@ -4584,7 +4584,7 @@
                 </a:solidFill>
                 <a:latin typeface="Yu Gothic"/>
               </a:rPr>
-              <a:t>328 tasks</a:t>
+              <a:t>352 tasks</a:t>
             </a:r>
           </a:p>
         </p:txBody>
@@ -6000,7 +6000,7 @@
               </a:defRPr>
             </a:pPr>
             <a:r>
-              <a:t>NotebookLM sources ready: 139</a:t>
+              <a:t>NotebookLM sources ready: 150</a:t>
             </a:r>
           </a:p>
           <a:p>

</xml_diff>

<commit_message>
fix(auth): enable default Basic Auth credentials fallback in managed runtime for T913
</commit_message>
<xml_diff>
--- a/exports/knowledge_flow/mighty_skill_bridge_ceo_presentation_2026-06-02.pptx
+++ b/exports/knowledge_flow/mighty_skill_bridge_ceo_presentation_2026-06-02.pptx
@@ -3240,7 +3240,7 @@
                 </a:solidFill>
                 <a:latin typeface="Yu Gothic"/>
               </a:rPr>
-              <a:t>01 / 08   NotebookLM CLI outline / notebook 75521ea6-6b9b-47b2-9508-50050d8ab2d5</a:t>
+              <a:t>01 / 08   NotebookLM CLI outline / notebook 4934c12b-b270-4739-97a1-b04b5b84eaaf</a:t>
             </a:r>
           </a:p>
         </p:txBody>
@@ -4134,7 +4134,7 @@
                 </a:solidFill>
                 <a:latin typeface="Yu Gothic"/>
               </a:rPr>
-              <a:t>02 / 08   NotebookLM CLI outline / notebook 75521ea6-6b9b-47b2-9508-50050d8ab2d5</a:t>
+              <a:t>02 / 08   NotebookLM CLI outline / notebook 4934c12b-b270-4739-97a1-b04b5b84eaaf</a:t>
             </a:r>
           </a:p>
         </p:txBody>
@@ -5044,7 +5044,7 @@
                 </a:solidFill>
                 <a:latin typeface="Yu Gothic"/>
               </a:rPr>
-              <a:t>03 / 08   NotebookLM CLI outline / notebook 75521ea6-6b9b-47b2-9508-50050d8ab2d5</a:t>
+              <a:t>03 / 08   NotebookLM CLI outline / notebook 4934c12b-b270-4739-97a1-b04b5b84eaaf</a:t>
             </a:r>
           </a:p>
         </p:txBody>
@@ -6184,7 +6184,7 @@
                 </a:solidFill>
                 <a:latin typeface="Yu Gothic"/>
               </a:rPr>
-              <a:t>04 / 08   NotebookLM CLI outline / notebook 75521ea6-6b9b-47b2-9508-50050d8ab2d5</a:t>
+              <a:t>04 / 08   NotebookLM CLI outline / notebook 4934c12b-b270-4739-97a1-b04b5b84eaaf</a:t>
             </a:r>
           </a:p>
         </p:txBody>
@@ -7393,7 +7393,7 @@
                 </a:solidFill>
                 <a:latin typeface="Yu Gothic"/>
               </a:rPr>
-              <a:t>05 / 08   NotebookLM CLI outline / notebook 75521ea6-6b9b-47b2-9508-50050d8ab2d5</a:t>
+              <a:t>05 / 08   NotebookLM CLI outline / notebook 4934c12b-b270-4739-97a1-b04b5b84eaaf</a:t>
             </a:r>
           </a:p>
         </p:txBody>
@@ -8183,7 +8183,7 @@
               </a:defRPr>
             </a:pPr>
             <a:r>
-              <a:t>NotebookLM notebook: 75521ea6-6b9b-47b2-9508-50050d8ab2d5</a:t>
+              <a:t>NotebookLM notebook: 4934c12b-b270-4739-97a1-b04b5b84eaaf</a:t>
             </a:r>
           </a:p>
           <a:p>
@@ -8383,7 +8383,7 @@
                 </a:solidFill>
                 <a:latin typeface="Yu Gothic"/>
               </a:rPr>
-              <a:t>06 / 08   NotebookLM CLI outline / notebook 75521ea6-6b9b-47b2-9508-50050d8ab2d5</a:t>
+              <a:t>06 / 08   NotebookLM CLI outline / notebook 4934c12b-b270-4739-97a1-b04b5b84eaaf</a:t>
             </a:r>
           </a:p>
         </p:txBody>
@@ -9646,7 +9646,7 @@
                 </a:solidFill>
                 <a:latin typeface="Yu Gothic"/>
               </a:rPr>
-              <a:t>07 / 08   NotebookLM CLI outline / notebook 75521ea6-6b9b-47b2-9508-50050d8ab2d5</a:t>
+              <a:t>07 / 08   NotebookLM CLI outline / notebook 4934c12b-b270-4739-97a1-b04b5b84eaaf</a:t>
             </a:r>
           </a:p>
         </p:txBody>
@@ -10750,7 +10750,7 @@
                 </a:solidFill>
                 <a:latin typeface="Yu Gothic"/>
               </a:rPr>
-              <a:t>08 / 08   NotebookLM CLI outline / notebook 75521ea6-6b9b-47b2-9508-50050d8ab2d5</a:t>
+              <a:t>08 / 08   NotebookLM CLI outline / notebook 4934c12b-b270-4739-97a1-b04b5b84eaaf</a:t>
             </a:r>
           </a:p>
         </p:txBody>

</xml_diff>

<commit_message>
chore(backup): close T870 with recovery evidence
</commit_message>
<xml_diff>
--- a/exports/knowledge_flow/mighty_skill_bridge_ceo_presentation_2026-06-02.pptx
+++ b/exports/knowledge_flow/mighty_skill_bridge_ceo_presentation_2026-06-02.pptx
@@ -4584,7 +4584,7 @@
                 </a:solidFill>
                 <a:latin typeface="Yu Gothic"/>
               </a:rPr>
-              <a:t>352 tasks</a:t>
+              <a:t>355 tasks</a:t>
             </a:r>
           </a:p>
         </p:txBody>
@@ -6000,7 +6000,7 @@
               </a:defRPr>
             </a:pPr>
             <a:r>
-              <a:t>NotebookLM sources ready: 150</a:t>
+              <a:t>NotebookLM sources ready: 158</a:t>
             </a:r>
           </a:p>
           <a:p>

</xml_diff>

<commit_message>
Polish Antigravity training demo deck
</commit_message>
<xml_diff>
--- a/exports/knowledge_flow/mighty_skill_bridge_ceo_presentation_2026-06-02.pptx
+++ b/exports/knowledge_flow/mighty_skill_bridge_ceo_presentation_2026-06-02.pptx
@@ -3240,7 +3240,7 @@
                 </a:solidFill>
                 <a:latin typeface="Yu Gothic"/>
               </a:rPr>
-              <a:t>01 / 08   NotebookLM CLI outline / notebook 4934c12b-b270-4739-97a1-b04b5b84eaaf</a:t>
+              <a:t>01 / 08   NotebookLM CLI outline / notebook 75521ea6-6b9b-47b2-9508-50050d8ab2d5</a:t>
             </a:r>
           </a:p>
         </p:txBody>
@@ -4134,7 +4134,7 @@
                 </a:solidFill>
                 <a:latin typeface="Yu Gothic"/>
               </a:rPr>
-              <a:t>02 / 08   NotebookLM CLI outline / notebook 4934c12b-b270-4739-97a1-b04b5b84eaaf</a:t>
+              <a:t>02 / 08   NotebookLM CLI outline / notebook 75521ea6-6b9b-47b2-9508-50050d8ab2d5</a:t>
             </a:r>
           </a:p>
         </p:txBody>
@@ -4584,7 +4584,7 @@
                 </a:solidFill>
                 <a:latin typeface="Yu Gothic"/>
               </a:rPr>
-              <a:t>359 tasks</a:t>
+              <a:t>371 tasks</a:t>
             </a:r>
           </a:p>
         </p:txBody>
@@ -5044,7 +5044,7 @@
                 </a:solidFill>
                 <a:latin typeface="Yu Gothic"/>
               </a:rPr>
-              <a:t>03 / 08   NotebookLM CLI outline / notebook 4934c12b-b270-4739-97a1-b04b5b84eaaf</a:t>
+              <a:t>03 / 08   NotebookLM CLI outline / notebook 75521ea6-6b9b-47b2-9508-50050d8ab2d5</a:t>
             </a:r>
           </a:p>
         </p:txBody>
@@ -6184,7 +6184,7 @@
                 </a:solidFill>
                 <a:latin typeface="Yu Gothic"/>
               </a:rPr>
-              <a:t>04 / 08   NotebookLM CLI outline / notebook 4934c12b-b270-4739-97a1-b04b5b84eaaf</a:t>
+              <a:t>04 / 08   NotebookLM CLI outline / notebook 75521ea6-6b9b-47b2-9508-50050d8ab2d5</a:t>
             </a:r>
           </a:p>
         </p:txBody>
@@ -7393,7 +7393,7 @@
                 </a:solidFill>
                 <a:latin typeface="Yu Gothic"/>
               </a:rPr>
-              <a:t>05 / 08   NotebookLM CLI outline / notebook 4934c12b-b270-4739-97a1-b04b5b84eaaf</a:t>
+              <a:t>05 / 08   NotebookLM CLI outline / notebook 75521ea6-6b9b-47b2-9508-50050d8ab2d5</a:t>
             </a:r>
           </a:p>
         </p:txBody>
@@ -8183,7 +8183,7 @@
               </a:defRPr>
             </a:pPr>
             <a:r>
-              <a:t>NotebookLM notebook: 4934c12b-b270-4739-97a1-b04b5b84eaaf</a:t>
+              <a:t>NotebookLM notebook: 75521ea6-6b9b-47b2-9508-50050d8ab2d5</a:t>
             </a:r>
           </a:p>
           <a:p>
@@ -8383,7 +8383,7 @@
                 </a:solidFill>
                 <a:latin typeface="Yu Gothic"/>
               </a:rPr>
-              <a:t>06 / 08   NotebookLM CLI outline / notebook 4934c12b-b270-4739-97a1-b04b5b84eaaf</a:t>
+              <a:t>06 / 08   NotebookLM CLI outline / notebook 75521ea6-6b9b-47b2-9508-50050d8ab2d5</a:t>
             </a:r>
           </a:p>
         </p:txBody>
@@ -9646,7 +9646,7 @@
                 </a:solidFill>
                 <a:latin typeface="Yu Gothic"/>
               </a:rPr>
-              <a:t>07 / 08   NotebookLM CLI outline / notebook 4934c12b-b270-4739-97a1-b04b5b84eaaf</a:t>
+              <a:t>07 / 08   NotebookLM CLI outline / notebook 75521ea6-6b9b-47b2-9508-50050d8ab2d5</a:t>
             </a:r>
           </a:p>
         </p:txBody>
@@ -10750,7 +10750,7 @@
                 </a:solidFill>
                 <a:latin typeface="Yu Gothic"/>
               </a:rPr>
-              <a:t>08 / 08   NotebookLM CLI outline / notebook 4934c12b-b270-4739-97a1-b04b5b84eaaf</a:t>
+              <a:t>08 / 08   NotebookLM CLI outline / notebook 75521ea6-6b9b-47b2-9508-50050d8ab2d5</a:t>
             </a:r>
           </a:p>
         </p:txBody>

</xml_diff>

<commit_message>
Improve Antigravity demo with hypothesis checks
</commit_message>
<xml_diff>
--- a/exports/knowledge_flow/mighty_skill_bridge_ceo_presentation_2026-06-02.pptx
+++ b/exports/knowledge_flow/mighty_skill_bridge_ceo_presentation_2026-06-02.pptx
@@ -3240,7 +3240,7 @@
                 </a:solidFill>
                 <a:latin typeface="Yu Gothic"/>
               </a:rPr>
-              <a:t>01 / 08   NotebookLM CLI outline / notebook 75521ea6-6b9b-47b2-9508-50050d8ab2d5</a:t>
+              <a:t>01 / 08   NotebookLM CLI outline / notebook 4934c12b-b270-4739-97a1-b04b5b84eaaf</a:t>
             </a:r>
           </a:p>
         </p:txBody>
@@ -4134,7 +4134,7 @@
                 </a:solidFill>
                 <a:latin typeface="Yu Gothic"/>
               </a:rPr>
-              <a:t>02 / 08   NotebookLM CLI outline / notebook 75521ea6-6b9b-47b2-9508-50050d8ab2d5</a:t>
+              <a:t>02 / 08   NotebookLM CLI outline / notebook 4934c12b-b270-4739-97a1-b04b5b84eaaf</a:t>
             </a:r>
           </a:p>
         </p:txBody>
@@ -4584,7 +4584,7 @@
                 </a:solidFill>
                 <a:latin typeface="Yu Gothic"/>
               </a:rPr>
-              <a:t>371 tasks</a:t>
+              <a:t>372 tasks</a:t>
             </a:r>
           </a:p>
         </p:txBody>
@@ -5044,7 +5044,7 @@
                 </a:solidFill>
                 <a:latin typeface="Yu Gothic"/>
               </a:rPr>
-              <a:t>03 / 08   NotebookLM CLI outline / notebook 75521ea6-6b9b-47b2-9508-50050d8ab2d5</a:t>
+              <a:t>03 / 08   NotebookLM CLI outline / notebook 4934c12b-b270-4739-97a1-b04b5b84eaaf</a:t>
             </a:r>
           </a:p>
         </p:txBody>
@@ -6000,7 +6000,7 @@
               </a:defRPr>
             </a:pPr>
             <a:r>
-              <a:t>NotebookLM sources ready: 158</a:t>
+              <a:t>NotebookLM sources ready: 160</a:t>
             </a:r>
           </a:p>
           <a:p>
@@ -6184,7 +6184,7 @@
                 </a:solidFill>
                 <a:latin typeface="Yu Gothic"/>
               </a:rPr>
-              <a:t>04 / 08   NotebookLM CLI outline / notebook 75521ea6-6b9b-47b2-9508-50050d8ab2d5</a:t>
+              <a:t>04 / 08   NotebookLM CLI outline / notebook 4934c12b-b270-4739-97a1-b04b5b84eaaf</a:t>
             </a:r>
           </a:p>
         </p:txBody>
@@ -7393,7 +7393,7 @@
                 </a:solidFill>
                 <a:latin typeface="Yu Gothic"/>
               </a:rPr>
-              <a:t>05 / 08   NotebookLM CLI outline / notebook 75521ea6-6b9b-47b2-9508-50050d8ab2d5</a:t>
+              <a:t>05 / 08   NotebookLM CLI outline / notebook 4934c12b-b270-4739-97a1-b04b5b84eaaf</a:t>
             </a:r>
           </a:p>
         </p:txBody>
@@ -8183,7 +8183,7 @@
               </a:defRPr>
             </a:pPr>
             <a:r>
-              <a:t>NotebookLM notebook: 75521ea6-6b9b-47b2-9508-50050d8ab2d5</a:t>
+              <a:t>NotebookLM notebook: 4934c12b-b270-4739-97a1-b04b5b84eaaf</a:t>
             </a:r>
           </a:p>
           <a:p>
@@ -8383,7 +8383,7 @@
                 </a:solidFill>
                 <a:latin typeface="Yu Gothic"/>
               </a:rPr>
-              <a:t>06 / 08   NotebookLM CLI outline / notebook 75521ea6-6b9b-47b2-9508-50050d8ab2d5</a:t>
+              <a:t>06 / 08   NotebookLM CLI outline / notebook 4934c12b-b270-4739-97a1-b04b5b84eaaf</a:t>
             </a:r>
           </a:p>
         </p:txBody>
@@ -9646,7 +9646,7 @@
                 </a:solidFill>
                 <a:latin typeface="Yu Gothic"/>
               </a:rPr>
-              <a:t>07 / 08   NotebookLM CLI outline / notebook 75521ea6-6b9b-47b2-9508-50050d8ab2d5</a:t>
+              <a:t>07 / 08   NotebookLM CLI outline / notebook 4934c12b-b270-4739-97a1-b04b5b84eaaf</a:t>
             </a:r>
           </a:p>
         </p:txBody>
@@ -10750,7 +10750,7 @@
                 </a:solidFill>
                 <a:latin typeface="Yu Gothic"/>
               </a:rPr>
-              <a:t>08 / 08   NotebookLM CLI outline / notebook 75521ea6-6b9b-47b2-9508-50050d8ab2d5</a:t>
+              <a:t>08 / 08   NotebookLM CLI outline / notebook 4934c12b-b270-4739-97a1-b04b5b84eaaf</a:t>
             </a:r>
           </a:p>
         </p:txBody>

</xml_diff>